<commit_message>
Unit 2 done, including videos; due dates centralized and fixed
</commit_message>
<xml_diff>
--- a/assets/Lecture-Related/Unit-01/01-Introduction.pptx
+++ b/assets/Lecture-Related/Unit-01/01-Introduction.pptx
@@ -272,7 +272,7 @@
       </p:grpSpPr>
       <p:sp>
         <p:nvSpPr>
-          <p:cNvPr id="1625145988" name="Google Shape;3;n"/>
+          <p:cNvPr id="1425001758" name="Google Shape;3;n"/>
           <p:cNvSpPr>
             <a:spLocks noChangeAspect="1" noGrp="1" noRot="1"/>
           </p:cNvSpPr>
@@ -323,7 +323,7 @@
       </p:sp>
       <p:sp>
         <p:nvSpPr>
-          <p:cNvPr id="1936171437" name="Google Shape;4;n"/>
+          <p:cNvPr id="1067073557" name="Google Shape;4;n"/>
           <p:cNvSpPr txBox="1">
             <a:spLocks noGrp="1"/>
           </p:cNvSpPr>
@@ -828,7 +828,7 @@
       </p:grpSpPr>
       <p:sp>
         <p:nvSpPr>
-          <p:cNvPr id="1484531851" name="Google Shape;104;p2:notes"/>
+          <p:cNvPr id="487994360" name="Google Shape;104;p2:notes"/>
           <p:cNvSpPr>
             <a:spLocks noChangeAspect="1" noGrp="1" noRot="1"/>
           </p:cNvSpPr>
@@ -879,7 +879,7 @@
       </p:sp>
       <p:sp>
         <p:nvSpPr>
-          <p:cNvPr id="63162558" name="Google Shape;105;p2:notes"/>
+          <p:cNvPr id="2063675751" name="Google Shape;105;p2:notes"/>
           <p:cNvSpPr txBox="1">
             <a:spLocks noGrp="1"/>
           </p:cNvSpPr>
@@ -951,7 +951,7 @@
       </p:grpSpPr>
       <p:sp>
         <p:nvSpPr>
-          <p:cNvPr id="1691644323" name="Slide Image Placeholder 1"/>
+          <p:cNvPr id="421618758" name="Slide Image Placeholder 1"/>
           <p:cNvSpPr>
             <a:spLocks noChangeAspect="1" noGrp="1" noRot="1"/>
           </p:cNvSpPr>
@@ -963,7 +963,7 @@
       </p:sp>
       <p:sp>
         <p:nvSpPr>
-          <p:cNvPr id="2109208985" name="Notes Placeholder 2"/>
+          <p:cNvPr id="1323619969" name="Notes Placeholder 2"/>
           <p:cNvSpPr>
             <a:spLocks noGrp="1"/>
           </p:cNvSpPr>
@@ -985,7 +985,7 @@
       </p:sp>
       <p:sp>
         <p:nvSpPr>
-          <p:cNvPr id="1539669315" name="Slide Number Placeholder 3"/>
+          <p:cNvPr id="1304725586" name="Slide Number Placeholder 3"/>
           <p:cNvSpPr>
             <a:spLocks noGrp="1"/>
           </p:cNvSpPr>
@@ -1036,7 +1036,7 @@
       </p:grpSpPr>
       <p:sp>
         <p:nvSpPr>
-          <p:cNvPr id="538978650" name="Google Shape;512;g32a7fc5f463_1_0:notes"/>
+          <p:cNvPr id="52684385" name="Google Shape;512;g32a7fc5f463_1_0:notes"/>
           <p:cNvSpPr>
             <a:spLocks noChangeAspect="1" noGrp="1" noRot="1"/>
           </p:cNvSpPr>
@@ -1087,7 +1087,7 @@
       </p:sp>
       <p:sp>
         <p:nvSpPr>
-          <p:cNvPr id="11506339" name="Google Shape;513;g32a7fc5f463_1_0:notes"/>
+          <p:cNvPr id="2030022610" name="Google Shape;513;g32a7fc5f463_1_0:notes"/>
           <p:cNvSpPr txBox="1">
             <a:spLocks noGrp="1"/>
           </p:cNvSpPr>
@@ -1163,7 +1163,7 @@
       </p:grpSpPr>
       <p:sp>
         <p:nvSpPr>
-          <p:cNvPr id="373838240" name="Google Shape;125;p4:notes"/>
+          <p:cNvPr id="536242489" name="Google Shape;125;p4:notes"/>
           <p:cNvSpPr>
             <a:spLocks noChangeAspect="1" noGrp="1" noRot="1"/>
           </p:cNvSpPr>
@@ -1214,7 +1214,7 @@
       </p:sp>
       <p:sp>
         <p:nvSpPr>
-          <p:cNvPr id="1579620681" name="Google Shape;126;p4:notes"/>
+          <p:cNvPr id="1587239419" name="Google Shape;126;p4:notes"/>
           <p:cNvSpPr txBox="1">
             <a:spLocks noGrp="1"/>
           </p:cNvSpPr>
@@ -1286,7 +1286,7 @@
       </p:grpSpPr>
       <p:sp>
         <p:nvSpPr>
-          <p:cNvPr id="213079279" name="Google Shape;132;p5:notes"/>
+          <p:cNvPr id="1518098554" name="Google Shape;132;p5:notes"/>
           <p:cNvSpPr>
             <a:spLocks noChangeAspect="1" noGrp="1" noRot="1"/>
           </p:cNvSpPr>
@@ -1337,7 +1337,7 @@
       </p:sp>
       <p:sp>
         <p:nvSpPr>
-          <p:cNvPr id="383275240" name="Google Shape;133;p5:notes"/>
+          <p:cNvPr id="1626137943" name="Google Shape;133;p5:notes"/>
           <p:cNvSpPr txBox="1">
             <a:spLocks noGrp="1"/>
           </p:cNvSpPr>
@@ -1409,7 +1409,7 @@
       </p:grpSpPr>
       <p:sp>
         <p:nvSpPr>
-          <p:cNvPr id="3037332" name="Google Shape;139;p6:notes"/>
+          <p:cNvPr id="325776843" name="Google Shape;139;p6:notes"/>
           <p:cNvSpPr>
             <a:spLocks noChangeAspect="1" noGrp="1" noRot="1"/>
           </p:cNvSpPr>
@@ -1460,7 +1460,7 @@
       </p:sp>
       <p:sp>
         <p:nvSpPr>
-          <p:cNvPr id="427728479" name="Google Shape;140;p6:notes"/>
+          <p:cNvPr id="1305469615" name="Google Shape;140;p6:notes"/>
           <p:cNvSpPr txBox="1">
             <a:spLocks noGrp="1"/>
           </p:cNvSpPr>
@@ -1507,7 +1507,7 @@
       </p:sp>
       <p:sp>
         <p:nvSpPr>
-          <p:cNvPr id="196615781" name="Google Shape;141;p6:notes"/>
+          <p:cNvPr id="1393772922" name="Google Shape;141;p6:notes"/>
           <p:cNvSpPr txBox="1">
             <a:spLocks noGrp="1"/>
           </p:cNvSpPr>
@@ -1601,7 +1601,7 @@
       </p:grpSpPr>
       <p:sp>
         <p:nvSpPr>
-          <p:cNvPr id="721306323" name="Google Shape;175;g320ca67c64f_0_233:notes"/>
+          <p:cNvPr id="1118602904" name="Google Shape;175;g320ca67c64f_0_233:notes"/>
           <p:cNvSpPr>
             <a:spLocks noChangeAspect="1" noGrp="1" noRot="1"/>
           </p:cNvSpPr>
@@ -1642,7 +1642,7 @@
       </p:sp>
       <p:sp>
         <p:nvSpPr>
-          <p:cNvPr id="341573" name="Google Shape;176;g320ca67c64f_0_233:notes"/>
+          <p:cNvPr id="1669562858" name="Google Shape;176;g320ca67c64f_0_233:notes"/>
           <p:cNvSpPr txBox="1">
             <a:spLocks noGrp="1"/>
           </p:cNvSpPr>
@@ -1706,7 +1706,7 @@
       </p:grpSpPr>
       <p:sp>
         <p:nvSpPr>
-          <p:cNvPr id="130402193" name="Google Shape;205;g320ca67c64f_0_259:notes"/>
+          <p:cNvPr id="105669943" name="Google Shape;205;g320ca67c64f_0_259:notes"/>
           <p:cNvSpPr>
             <a:spLocks noChangeAspect="1" noGrp="1" noRot="1"/>
           </p:cNvSpPr>
@@ -1747,7 +1747,7 @@
       </p:sp>
       <p:sp>
         <p:nvSpPr>
-          <p:cNvPr id="427379629" name="Google Shape;206;g320ca67c64f_0_259:notes"/>
+          <p:cNvPr id="1518886719" name="Google Shape;206;g320ca67c64f_0_259:notes"/>
           <p:cNvSpPr txBox="1">
             <a:spLocks noGrp="1"/>
           </p:cNvSpPr>
@@ -1811,7 +1811,7 @@
       </p:grpSpPr>
       <p:sp>
         <p:nvSpPr>
-          <p:cNvPr id="676983856" name="Google Shape;212;g320ca67c64f_0_265:notes"/>
+          <p:cNvPr id="912600508" name="Google Shape;212;g320ca67c64f_0_265:notes"/>
           <p:cNvSpPr>
             <a:spLocks noChangeAspect="1" noGrp="1" noRot="1"/>
           </p:cNvSpPr>
@@ -1852,7 +1852,7 @@
       </p:sp>
       <p:sp>
         <p:nvSpPr>
-          <p:cNvPr id="1995938690" name="Google Shape;213;g320ca67c64f_0_265:notes"/>
+          <p:cNvPr id="921627833" name="Google Shape;213;g320ca67c64f_0_265:notes"/>
           <p:cNvSpPr txBox="1">
             <a:spLocks noGrp="1"/>
           </p:cNvSpPr>
@@ -1916,7 +1916,7 @@
       </p:grpSpPr>
       <p:sp>
         <p:nvSpPr>
-          <p:cNvPr id="1699343419" name="Google Shape;174;g2f6e17132a5_0_85:notes"/>
+          <p:cNvPr id="302069586" name="Google Shape;174;g2f6e17132a5_0_85:notes"/>
           <p:cNvSpPr>
             <a:spLocks noChangeAspect="1" noGrp="1" noRot="1"/>
           </p:cNvSpPr>
@@ -1957,7 +1957,7 @@
       </p:sp>
       <p:sp>
         <p:nvSpPr>
-          <p:cNvPr id="477314661" name="Google Shape;175;g2f6e17132a5_0_85:notes"/>
+          <p:cNvPr id="1453689169" name="Google Shape;175;g2f6e17132a5_0_85:notes"/>
           <p:cNvSpPr txBox="1">
             <a:spLocks noGrp="1"/>
           </p:cNvSpPr>
@@ -2021,7 +2021,7 @@
       </p:grpSpPr>
       <p:sp>
         <p:nvSpPr>
-          <p:cNvPr id="1556110874" name="Slide Image Placeholder 1"/>
+          <p:cNvPr id="251021677" name="Slide Image Placeholder 1"/>
           <p:cNvSpPr>
             <a:spLocks noChangeAspect="1" noGrp="1" noRot="1"/>
           </p:cNvSpPr>
@@ -2033,7 +2033,7 @@
       </p:sp>
       <p:sp>
         <p:nvSpPr>
-          <p:cNvPr id="2134501095" name="Notes Placeholder 2"/>
+          <p:cNvPr id="1297093787" name="Notes Placeholder 2"/>
           <p:cNvSpPr>
             <a:spLocks noGrp="1"/>
           </p:cNvSpPr>
@@ -2055,7 +2055,7 @@
       </p:sp>
       <p:sp>
         <p:nvSpPr>
-          <p:cNvPr id="306455340" name="Slide Number Placeholder 3"/>
+          <p:cNvPr id="1828948971" name="Slide Number Placeholder 3"/>
           <p:cNvSpPr>
             <a:spLocks noGrp="1"/>
           </p:cNvSpPr>
@@ -2106,7 +2106,7 @@
       </p:grpSpPr>
       <p:sp>
         <p:nvSpPr>
-          <p:cNvPr id="316614221" name="Google Shape;10;p50"/>
+          <p:cNvPr id="814708721" name="Google Shape;10;p50"/>
           <p:cNvSpPr txBox="1">
             <a:spLocks noGrp="1"/>
           </p:cNvSpPr>
@@ -2269,7 +2269,7 @@
       </p:sp>
       <p:sp>
         <p:nvSpPr>
-          <p:cNvPr id="1568656638" name="Google Shape;11;p50"/>
+          <p:cNvPr id="1181373077" name="Google Shape;11;p50"/>
           <p:cNvSpPr txBox="1">
             <a:spLocks noGrp="1"/>
           </p:cNvSpPr>
@@ -2432,7 +2432,7 @@
       </p:sp>
       <p:sp>
         <p:nvSpPr>
-          <p:cNvPr id="141400587" name="Google Shape;12;p50"/>
+          <p:cNvPr id="1237459257" name="Google Shape;12;p50"/>
           <p:cNvSpPr txBox="1">
             <a:spLocks noGrp="1"/>
           </p:cNvSpPr>
@@ -2730,7 +2730,7 @@
       </p:grpSpPr>
       <p:sp>
         <p:nvSpPr>
-          <p:cNvPr id="1019508147" name="Google Shape;46;p60"/>
+          <p:cNvPr id="1912442773" name="Google Shape;46;p60"/>
           <p:cNvSpPr txBox="1">
             <a:spLocks noGrp="1"/>
           </p:cNvSpPr>
@@ -2893,7 +2893,7 @@
       </p:sp>
       <p:sp>
         <p:nvSpPr>
-          <p:cNvPr id="126460009" name="Google Shape;47;p60"/>
+          <p:cNvPr id="358675727" name="Google Shape;47;p60"/>
           <p:cNvSpPr txBox="1">
             <a:spLocks noGrp="1"/>
           </p:cNvSpPr>
@@ -3056,7 +3056,7 @@
       </p:sp>
       <p:sp>
         <p:nvSpPr>
-          <p:cNvPr id="1465784465" name="Google Shape;48;p60"/>
+          <p:cNvPr id="374068796" name="Google Shape;48;p60"/>
           <p:cNvSpPr txBox="1"/>
           <p:nvPr/>
         </p:nvSpPr>
@@ -3121,7 +3121,7 @@
       </p:sp>
       <p:sp>
         <p:nvSpPr>
-          <p:cNvPr id="1597639089" name="Google Shape;49;p60"/>
+          <p:cNvPr id="1657656021" name="Google Shape;49;p60"/>
           <p:cNvSpPr txBox="1">
             <a:spLocks noGrp="1"/>
           </p:cNvSpPr>
@@ -3426,7 +3426,7 @@
       </p:grpSpPr>
       <p:sp>
         <p:nvSpPr>
-          <p:cNvPr id="1573834622" name="Google Shape;55;g320ca67c64f_0_413"/>
+          <p:cNvPr id="415398943" name="Google Shape;55;g320ca67c64f_0_413"/>
           <p:cNvSpPr txBox="1">
             <a:spLocks noGrp="1"/>
           </p:cNvSpPr>
@@ -3558,7 +3558,7 @@
       </p:sp>
       <p:sp>
         <p:nvSpPr>
-          <p:cNvPr id="1231707326" name="Google Shape;56;g320ca67c64f_0_413"/>
+          <p:cNvPr id="1581640630" name="Google Shape;56;g320ca67c64f_0_413"/>
           <p:cNvSpPr txBox="1">
             <a:spLocks noGrp="1"/>
           </p:cNvSpPr>
@@ -3762,7 +3762,7 @@
       </p:sp>
       <p:sp>
         <p:nvSpPr>
-          <p:cNvPr id="1766395519" name="Google Shape;57;g320ca67c64f_0_413"/>
+          <p:cNvPr id="226468705" name="Google Shape;57;g320ca67c64f_0_413"/>
           <p:cNvSpPr txBox="1">
             <a:spLocks noGrp="1"/>
           </p:cNvSpPr>
@@ -3937,7 +3937,7 @@
       </p:grpSpPr>
       <p:sp>
         <p:nvSpPr>
-          <p:cNvPr id="18108515" name="Google Shape;59;g320ca67c64f_0_417"/>
+          <p:cNvPr id="1659398660" name="Google Shape;59;g320ca67c64f_0_417"/>
           <p:cNvSpPr txBox="1">
             <a:spLocks noGrp="1"/>
           </p:cNvSpPr>
@@ -4069,7 +4069,7 @@
       </p:sp>
       <p:sp>
         <p:nvSpPr>
-          <p:cNvPr id="1668132437" name="Google Shape;60;g320ca67c64f_0_417"/>
+          <p:cNvPr id="1087281927" name="Google Shape;60;g320ca67c64f_0_417"/>
           <p:cNvSpPr txBox="1">
             <a:spLocks noGrp="1"/>
           </p:cNvSpPr>
@@ -4237,7 +4237,7 @@
       </p:grpSpPr>
       <p:sp>
         <p:nvSpPr>
-          <p:cNvPr id="1599932240" name="Google Shape;62;g320ca67c64f_0_420"/>
+          <p:cNvPr id="1925676178" name="Google Shape;62;g320ca67c64f_0_420"/>
           <p:cNvSpPr txBox="1">
             <a:spLocks noGrp="1"/>
           </p:cNvSpPr>
@@ -4369,7 +4369,7 @@
       </p:sp>
       <p:sp>
         <p:nvSpPr>
-          <p:cNvPr id="2115210305" name="Google Shape;63;g320ca67c64f_0_420"/>
+          <p:cNvPr id="930224330" name="Google Shape;63;g320ca67c64f_0_420"/>
           <p:cNvSpPr txBox="1">
             <a:spLocks noGrp="1"/>
           </p:cNvSpPr>
@@ -4501,7 +4501,7 @@
       </p:sp>
       <p:sp>
         <p:nvSpPr>
-          <p:cNvPr id="156885471" name="Google Shape;64;g320ca67c64f_0_420"/>
+          <p:cNvPr id="1371753292" name="Google Shape;64;g320ca67c64f_0_420"/>
           <p:cNvSpPr txBox="1">
             <a:spLocks noGrp="1"/>
           </p:cNvSpPr>
@@ -4606,7 +4606,7 @@
       </p:grpSpPr>
       <p:sp>
         <p:nvSpPr>
-          <p:cNvPr id="2139684100" name="Google Shape;66;g320ca67c64f_0_424"/>
+          <p:cNvPr id="256725260" name="Google Shape;66;g320ca67c64f_0_424"/>
           <p:cNvSpPr txBox="1">
             <a:spLocks noGrp="1"/>
           </p:cNvSpPr>
@@ -4738,7 +4738,7 @@
       </p:sp>
       <p:sp>
         <p:nvSpPr>
-          <p:cNvPr id="1557740497" name="Google Shape;67;g320ca67c64f_0_424"/>
+          <p:cNvPr id="1370955283" name="Google Shape;67;g320ca67c64f_0_424"/>
           <p:cNvSpPr txBox="1">
             <a:spLocks noGrp="1"/>
           </p:cNvSpPr>
@@ -4870,7 +4870,7 @@
       </p:sp>
       <p:sp>
         <p:nvSpPr>
-          <p:cNvPr id="117168415" name="Google Shape;68;g320ca67c64f_0_424"/>
+          <p:cNvPr id="99618760" name="Google Shape;68;g320ca67c64f_0_424"/>
           <p:cNvSpPr txBox="1">
             <a:spLocks noGrp="1"/>
           </p:cNvSpPr>
@@ -5038,7 +5038,7 @@
       </p:grpSpPr>
       <p:sp>
         <p:nvSpPr>
-          <p:cNvPr id="746384720" name="Google Shape;70;g320ca67c64f_0_428"/>
+          <p:cNvPr id="1129999272" name="Google Shape;70;g320ca67c64f_0_428"/>
           <p:cNvSpPr txBox="1">
             <a:spLocks noGrp="1"/>
           </p:cNvSpPr>
@@ -5170,7 +5170,7 @@
       </p:sp>
       <p:sp>
         <p:nvSpPr>
-          <p:cNvPr id="37807806" name="Google Shape;71;g320ca67c64f_0_428"/>
+          <p:cNvPr id="2029277916" name="Google Shape;71;g320ca67c64f_0_428"/>
           <p:cNvSpPr txBox="1">
             <a:spLocks noGrp="1"/>
           </p:cNvSpPr>
@@ -5302,7 +5302,7 @@
       </p:sp>
       <p:sp>
         <p:nvSpPr>
-          <p:cNvPr id="1875387681" name="Google Shape;72;g320ca67c64f_0_428"/>
+          <p:cNvPr id="1748525589" name="Google Shape;72;g320ca67c64f_0_428"/>
           <p:cNvSpPr txBox="1"/>
           <p:nvPr/>
         </p:nvSpPr>
@@ -5359,7 +5359,7 @@
       </p:sp>
       <p:sp>
         <p:nvSpPr>
-          <p:cNvPr id="1387554189" name="Google Shape;73;g320ca67c64f_0_428"/>
+          <p:cNvPr id="1458670458" name="Google Shape;73;g320ca67c64f_0_428"/>
           <p:cNvSpPr txBox="1">
             <a:spLocks noGrp="1"/>
           </p:cNvSpPr>
@@ -5534,7 +5534,7 @@
       </p:grpSpPr>
       <p:sp>
         <p:nvSpPr>
-          <p:cNvPr id="756136483" name="Google Shape;75;g320ca67c64f_0_433"/>
+          <p:cNvPr id="381010814" name="Google Shape;75;g320ca67c64f_0_433"/>
           <p:cNvSpPr txBox="1">
             <a:spLocks noGrp="1"/>
           </p:cNvSpPr>
@@ -5666,7 +5666,7 @@
       </p:sp>
       <p:sp>
         <p:nvSpPr>
-          <p:cNvPr id="1835540633" name="Google Shape;76;g320ca67c64f_0_433"/>
+          <p:cNvPr id="1412834401" name="Google Shape;76;g320ca67c64f_0_433"/>
           <p:cNvSpPr txBox="1">
             <a:spLocks noGrp="1"/>
           </p:cNvSpPr>
@@ -5841,7 +5841,7 @@
       </p:grpSpPr>
       <p:sp>
         <p:nvSpPr>
-          <p:cNvPr id="724670085" name="Google Shape;78;g320ca67c64f_0_436"/>
+          <p:cNvPr id="1869691426" name="Google Shape;78;g320ca67c64f_0_436"/>
           <p:cNvSpPr txBox="1">
             <a:spLocks noGrp="1"/>
           </p:cNvSpPr>
@@ -5888,7 +5888,7 @@
       </p:sp>
       <p:sp>
         <p:nvSpPr>
-          <p:cNvPr id="2022305119" name="Google Shape;79;g320ca67c64f_0_436"/>
+          <p:cNvPr id="1620382901" name="Google Shape;79;g320ca67c64f_0_436"/>
           <p:cNvSpPr txBox="1">
             <a:spLocks noGrp="1"/>
           </p:cNvSpPr>
@@ -6063,7 +6063,7 @@
       </p:grpSpPr>
       <p:sp>
         <p:nvSpPr>
-          <p:cNvPr id="144491207" name="Google Shape;81;g320ca67c64f_0_439"/>
+          <p:cNvPr id="362143709" name="Google Shape;81;g320ca67c64f_0_439"/>
           <p:cNvSpPr txBox="1">
             <a:spLocks noGrp="1"/>
           </p:cNvSpPr>
@@ -6231,7 +6231,7 @@
       </p:grpSpPr>
       <p:sp>
         <p:nvSpPr>
-          <p:cNvPr id="1802135539" name="Google Shape;83;g320ca67c64f_0_441"/>
+          <p:cNvPr id="481983044" name="Google Shape;83;g320ca67c64f_0_441"/>
           <p:cNvSpPr txBox="1">
             <a:spLocks noGrp="1"/>
           </p:cNvSpPr>
@@ -6363,7 +6363,7 @@
       </p:sp>
       <p:sp>
         <p:nvSpPr>
-          <p:cNvPr id="1671158968" name="Google Shape;84;g320ca67c64f_0_441"/>
+          <p:cNvPr id="260310775" name="Google Shape;84;g320ca67c64f_0_441"/>
           <p:cNvSpPr txBox="1">
             <a:spLocks noGrp="1"/>
           </p:cNvSpPr>
@@ -6495,7 +6495,7 @@
       </p:sp>
       <p:sp>
         <p:nvSpPr>
-          <p:cNvPr id="230565374" name="Google Shape;85;g320ca67c64f_0_441"/>
+          <p:cNvPr id="670450001" name="Google Shape;85;g320ca67c64f_0_441"/>
           <p:cNvSpPr txBox="1">
             <a:spLocks noGrp="1"/>
           </p:cNvSpPr>
@@ -6607,7 +6607,7 @@
       </p:grpSpPr>
       <p:sp>
         <p:nvSpPr>
-          <p:cNvPr id="193534934" name="Google Shape;14;p51"/>
+          <p:cNvPr id="1303193589" name="Google Shape;14;p51"/>
           <p:cNvSpPr txBox="1">
             <a:spLocks noGrp="1"/>
           </p:cNvSpPr>
@@ -6770,7 +6770,7 @@
       </p:sp>
       <p:sp>
         <p:nvSpPr>
-          <p:cNvPr id="2123578941" name="Google Shape;15;p51"/>
+          <p:cNvPr id="363343883" name="Google Shape;15;p51"/>
           <p:cNvSpPr txBox="1">
             <a:spLocks noGrp="1"/>
           </p:cNvSpPr>
@@ -6978,7 +6978,7 @@
       </p:sp>
       <p:sp>
         <p:nvSpPr>
-          <p:cNvPr id="1315884419" name="Google Shape;16;p51"/>
+          <p:cNvPr id="1063340785" name="Google Shape;16;p51"/>
           <p:cNvSpPr txBox="1">
             <a:spLocks noGrp="1"/>
           </p:cNvSpPr>
@@ -7276,7 +7276,7 @@
       </p:grpSpPr>
       <p:sp>
         <p:nvSpPr>
-          <p:cNvPr id="941585296" name="Google Shape;91;g320ca67c64f_0_449"/>
+          <p:cNvPr id="1677914314" name="Google Shape;91;g320ca67c64f_0_449"/>
           <p:cNvSpPr txBox="1">
             <a:spLocks noGrp="1"/>
           </p:cNvSpPr>
@@ -7408,7 +7408,7 @@
       </p:sp>
       <p:sp>
         <p:nvSpPr>
-          <p:cNvPr id="1852823180" name="Google Shape;92;g320ca67c64f_0_449"/>
+          <p:cNvPr id="1375218626" name="Google Shape;92;g320ca67c64f_0_449"/>
           <p:cNvSpPr txBox="1">
             <a:spLocks noGrp="1"/>
           </p:cNvSpPr>
@@ -7540,7 +7540,7 @@
       </p:sp>
       <p:sp>
         <p:nvSpPr>
-          <p:cNvPr id="1948912989" name="Google Shape;93;g320ca67c64f_0_449"/>
+          <p:cNvPr id="1233415897" name="Google Shape;93;g320ca67c64f_0_449"/>
           <p:cNvSpPr txBox="1"/>
           <p:nvPr/>
         </p:nvSpPr>
@@ -7597,7 +7597,7 @@
       </p:sp>
       <p:sp>
         <p:nvSpPr>
-          <p:cNvPr id="2102758548" name="Google Shape;94;g320ca67c64f_0_449"/>
+          <p:cNvPr id="491691733" name="Google Shape;94;g320ca67c64f_0_449"/>
           <p:cNvSpPr txBox="1">
             <a:spLocks noGrp="1"/>
           </p:cNvSpPr>
@@ -7772,7 +7772,7 @@
       </p:grpSpPr>
       <p:sp>
         <p:nvSpPr>
-          <p:cNvPr id="2072819892" name="Google Shape;10;p2"/>
+          <p:cNvPr id="1550179916" name="Google Shape;10;p2"/>
           <p:cNvSpPr txBox="1">
             <a:spLocks noGrp="1"/>
           </p:cNvSpPr>
@@ -7904,7 +7904,7 @@
       </p:sp>
       <p:sp>
         <p:nvSpPr>
-          <p:cNvPr id="1602461024" name="Google Shape;11;p2"/>
+          <p:cNvPr id="579463067" name="Google Shape;11;p2"/>
           <p:cNvSpPr txBox="1">
             <a:spLocks noGrp="1"/>
           </p:cNvSpPr>
@@ -8108,7 +8108,7 @@
       </p:sp>
       <p:sp>
         <p:nvSpPr>
-          <p:cNvPr id="1823099651" name="Google Shape;12;p2"/>
+          <p:cNvPr id="1890773952" name="Google Shape;12;p2"/>
           <p:cNvSpPr txBox="1">
             <a:spLocks noGrp="1"/>
           </p:cNvSpPr>
@@ -8283,7 +8283,7 @@
       </p:grpSpPr>
       <p:sp>
         <p:nvSpPr>
-          <p:cNvPr id="1437984595" name="Google Shape;14;p3"/>
+          <p:cNvPr id="2139922709" name="Google Shape;14;p3"/>
           <p:cNvSpPr txBox="1">
             <a:spLocks noGrp="1"/>
           </p:cNvSpPr>
@@ -8415,7 +8415,7 @@
       </p:sp>
       <p:sp>
         <p:nvSpPr>
-          <p:cNvPr id="1653456728" name="Google Shape;15;p3"/>
+          <p:cNvPr id="502031955" name="Google Shape;15;p3"/>
           <p:cNvSpPr txBox="1">
             <a:spLocks noGrp="1"/>
           </p:cNvSpPr>
@@ -8583,7 +8583,7 @@
       </p:grpSpPr>
       <p:sp>
         <p:nvSpPr>
-          <p:cNvPr id="1420100962" name="Google Shape;17;p4"/>
+          <p:cNvPr id="632781383" name="Google Shape;17;p4"/>
           <p:cNvSpPr txBox="1">
             <a:spLocks noGrp="1"/>
           </p:cNvSpPr>
@@ -8715,7 +8715,7 @@
       </p:sp>
       <p:sp>
         <p:nvSpPr>
-          <p:cNvPr id="136076948" name="Google Shape;18;p4"/>
+          <p:cNvPr id="1678109193" name="Google Shape;18;p4"/>
           <p:cNvSpPr txBox="1">
             <a:spLocks noGrp="1"/>
           </p:cNvSpPr>
@@ -8847,7 +8847,7 @@
       </p:sp>
       <p:sp>
         <p:nvSpPr>
-          <p:cNvPr id="712589094" name="Google Shape;19;p4"/>
+          <p:cNvPr id="1498631566" name="Google Shape;19;p4"/>
           <p:cNvSpPr txBox="1">
             <a:spLocks noGrp="1"/>
           </p:cNvSpPr>
@@ -8952,7 +8952,7 @@
       </p:grpSpPr>
       <p:sp>
         <p:nvSpPr>
-          <p:cNvPr id="1573120969" name="Google Shape;21;p5"/>
+          <p:cNvPr id="868026931" name="Google Shape;21;p5"/>
           <p:cNvSpPr txBox="1">
             <a:spLocks noGrp="1"/>
           </p:cNvSpPr>
@@ -9084,7 +9084,7 @@
       </p:sp>
       <p:sp>
         <p:nvSpPr>
-          <p:cNvPr id="1799017524" name="Google Shape;22;p5"/>
+          <p:cNvPr id="1127926154" name="Google Shape;22;p5"/>
           <p:cNvSpPr txBox="1">
             <a:spLocks noGrp="1"/>
           </p:cNvSpPr>
@@ -9216,7 +9216,7 @@
       </p:sp>
       <p:sp>
         <p:nvSpPr>
-          <p:cNvPr id="329598248" name="Google Shape;23;p5"/>
+          <p:cNvPr id="1432904548" name="Google Shape;23;p5"/>
           <p:cNvSpPr txBox="1">
             <a:spLocks noGrp="1"/>
           </p:cNvSpPr>
@@ -9384,7 +9384,7 @@
       </p:grpSpPr>
       <p:sp>
         <p:nvSpPr>
-          <p:cNvPr id="950534443" name="Google Shape;25;p6"/>
+          <p:cNvPr id="912987006" name="Google Shape;25;p6"/>
           <p:cNvSpPr txBox="1">
             <a:spLocks noGrp="1"/>
           </p:cNvSpPr>
@@ -9516,7 +9516,7 @@
       </p:sp>
       <p:sp>
         <p:nvSpPr>
-          <p:cNvPr id="245767364" name="Google Shape;26;p6"/>
+          <p:cNvPr id="797579661" name="Google Shape;26;p6"/>
           <p:cNvSpPr txBox="1">
             <a:spLocks noGrp="1"/>
           </p:cNvSpPr>
@@ -9648,7 +9648,7 @@
       </p:sp>
       <p:sp>
         <p:nvSpPr>
-          <p:cNvPr id="1692074476" name="Google Shape;27;p6"/>
+          <p:cNvPr id="1076640688" name="Google Shape;27;p6"/>
           <p:cNvSpPr txBox="1"/>
           <p:nvPr/>
         </p:nvSpPr>
@@ -9705,7 +9705,7 @@
       </p:sp>
       <p:sp>
         <p:nvSpPr>
-          <p:cNvPr id="2025152972" name="Google Shape;28;p6"/>
+          <p:cNvPr id="1002012809" name="Google Shape;28;p6"/>
           <p:cNvSpPr txBox="1">
             <a:spLocks noGrp="1"/>
           </p:cNvSpPr>
@@ -9880,7 +9880,7 @@
       </p:grpSpPr>
       <p:sp>
         <p:nvSpPr>
-          <p:cNvPr id="1322775848" name="Google Shape;30;p7"/>
+          <p:cNvPr id="1339255870" name="Google Shape;30;p7"/>
           <p:cNvSpPr txBox="1">
             <a:spLocks noGrp="1"/>
           </p:cNvSpPr>
@@ -10012,7 +10012,7 @@
       </p:sp>
       <p:sp>
         <p:nvSpPr>
-          <p:cNvPr id="217497986" name="Google Shape;31;p7"/>
+          <p:cNvPr id="1893338594" name="Google Shape;31;p7"/>
           <p:cNvSpPr txBox="1">
             <a:spLocks noGrp="1"/>
           </p:cNvSpPr>
@@ -10187,7 +10187,7 @@
       </p:grpSpPr>
       <p:sp>
         <p:nvSpPr>
-          <p:cNvPr id="617652203" name="Google Shape;33;p8"/>
+          <p:cNvPr id="1680955460" name="Google Shape;33;p8"/>
           <p:cNvSpPr txBox="1">
             <a:spLocks noGrp="1"/>
           </p:cNvSpPr>
@@ -10234,7 +10234,7 @@
       </p:sp>
       <p:sp>
         <p:nvSpPr>
-          <p:cNvPr id="1034001125" name="Google Shape;34;p8"/>
+          <p:cNvPr id="271968667" name="Google Shape;34;p8"/>
           <p:cNvSpPr txBox="1">
             <a:spLocks noGrp="1"/>
           </p:cNvSpPr>
@@ -10409,7 +10409,7 @@
       </p:grpSpPr>
       <p:sp>
         <p:nvSpPr>
-          <p:cNvPr id="1146386135" name="Google Shape;36;p9"/>
+          <p:cNvPr id="1126429506" name="Google Shape;36;p9"/>
           <p:cNvSpPr txBox="1">
             <a:spLocks noGrp="1"/>
           </p:cNvSpPr>
@@ -10577,7 +10577,7 @@
       </p:grpSpPr>
       <p:sp>
         <p:nvSpPr>
-          <p:cNvPr id="2039881145" name="Google Shape;38;p10"/>
+          <p:cNvPr id="1255611221" name="Google Shape;38;p10"/>
           <p:cNvSpPr txBox="1">
             <a:spLocks noGrp="1"/>
           </p:cNvSpPr>
@@ -10709,7 +10709,7 @@
       </p:sp>
       <p:sp>
         <p:nvSpPr>
-          <p:cNvPr id="350257935" name="Google Shape;39;p10"/>
+          <p:cNvPr id="795082382" name="Google Shape;39;p10"/>
           <p:cNvSpPr txBox="1">
             <a:spLocks noGrp="1"/>
           </p:cNvSpPr>
@@ -10841,7 +10841,7 @@
       </p:sp>
       <p:sp>
         <p:nvSpPr>
-          <p:cNvPr id="1434541667" name="Google Shape;40;p10"/>
+          <p:cNvPr id="1251715646" name="Google Shape;40;p10"/>
           <p:cNvSpPr txBox="1">
             <a:spLocks noGrp="1"/>
           </p:cNvSpPr>
@@ -10946,7 +10946,7 @@
       </p:grpSpPr>
       <p:sp>
         <p:nvSpPr>
-          <p:cNvPr id="867832377" name="Google Shape;18;p52"/>
+          <p:cNvPr id="395926809" name="Google Shape;18;p52"/>
           <p:cNvSpPr txBox="1">
             <a:spLocks noGrp="1"/>
           </p:cNvSpPr>
@@ -11109,7 +11109,7 @@
       </p:sp>
       <p:sp>
         <p:nvSpPr>
-          <p:cNvPr id="1536673204" name="Google Shape;19;p52"/>
+          <p:cNvPr id="1876326890" name="Google Shape;19;p52"/>
           <p:cNvSpPr txBox="1">
             <a:spLocks noGrp="1"/>
           </p:cNvSpPr>
@@ -11272,7 +11272,7 @@
       </p:sp>
       <p:sp>
         <p:nvSpPr>
-          <p:cNvPr id="2137830090" name="Google Shape;20;p52"/>
+          <p:cNvPr id="97575985" name="Google Shape;20;p52"/>
           <p:cNvSpPr txBox="1">
             <a:spLocks noGrp="1"/>
           </p:cNvSpPr>
@@ -11570,7 +11570,7 @@
       </p:grpSpPr>
       <p:sp>
         <p:nvSpPr>
-          <p:cNvPr id="1870040883" name="Google Shape;46;p12"/>
+          <p:cNvPr id="1892080386" name="Google Shape;46;p12"/>
           <p:cNvSpPr txBox="1">
             <a:spLocks noGrp="1"/>
           </p:cNvSpPr>
@@ -11702,7 +11702,7 @@
       </p:sp>
       <p:sp>
         <p:nvSpPr>
-          <p:cNvPr id="30612724" name="Google Shape;47;p12"/>
+          <p:cNvPr id="1564117149" name="Google Shape;47;p12"/>
           <p:cNvSpPr txBox="1">
             <a:spLocks noGrp="1"/>
           </p:cNvSpPr>
@@ -11834,7 +11834,7 @@
       </p:sp>
       <p:sp>
         <p:nvSpPr>
-          <p:cNvPr id="1381796410" name="Google Shape;48;p12"/>
+          <p:cNvPr id="1274484304" name="Google Shape;48;p12"/>
           <p:cNvSpPr txBox="1"/>
           <p:nvPr/>
         </p:nvSpPr>
@@ -11891,7 +11891,7 @@
       </p:sp>
       <p:sp>
         <p:nvSpPr>
-          <p:cNvPr id="1749330120" name="Google Shape;49;p12"/>
+          <p:cNvPr id="639337732" name="Google Shape;49;p12"/>
           <p:cNvSpPr txBox="1">
             <a:spLocks noGrp="1"/>
           </p:cNvSpPr>
@@ -12069,7 +12069,7 @@
       </p:grpSpPr>
       <p:sp>
         <p:nvSpPr>
-          <p:cNvPr id="1408568459" name="Rectangle 6"/>
+          <p:cNvPr id="512622946" name="Rectangle 6"/>
           <p:cNvSpPr/>
           <p:nvPr userDrawn="1"/>
         </p:nvSpPr>
@@ -12093,7 +12093,7 @@
       </p:sp>
       <p:sp>
         <p:nvSpPr>
-          <p:cNvPr id="917723984" name="Rectangle 16"/>
+          <p:cNvPr id="2081431194" name="Rectangle 16"/>
           <p:cNvSpPr/>
           <p:nvPr userDrawn="1"/>
         </p:nvSpPr>
@@ -12117,7 +12117,7 @@
       </p:sp>
       <p:sp>
         <p:nvSpPr>
-          <p:cNvPr id="1601136283" name="Rectangle 18"/>
+          <p:cNvPr id="1353087677" name="Rectangle 18"/>
           <p:cNvSpPr/>
           <p:nvPr userDrawn="1"/>
         </p:nvSpPr>
@@ -12141,7 +12141,7 @@
       </p:sp>
       <p:sp>
         <p:nvSpPr>
-          <p:cNvPr id="489481198" name="Rectangle 19"/>
+          <p:cNvPr id="946551818" name="Rectangle 19"/>
           <p:cNvSpPr/>
           <p:nvPr userDrawn="1"/>
         </p:nvSpPr>
@@ -12165,7 +12165,7 @@
       </p:sp>
       <p:sp>
         <p:nvSpPr>
-          <p:cNvPr id="48539602" name="Rectangle 21"/>
+          <p:cNvPr id="1264230988" name="Rectangle 21"/>
           <p:cNvSpPr/>
           <p:nvPr userDrawn="1"/>
         </p:nvSpPr>
@@ -12189,7 +12189,7 @@
       </p:sp>
       <p:sp>
         <p:nvSpPr>
-          <p:cNvPr id="1347617664" name="Rectangle 22"/>
+          <p:cNvPr id="761759559" name="Rectangle 22"/>
           <p:cNvSpPr/>
           <p:nvPr userDrawn="1"/>
         </p:nvSpPr>
@@ -12213,7 +12213,7 @@
       </p:sp>
       <p:sp>
         <p:nvSpPr>
-          <p:cNvPr id="838968280" name="Rectangle 24"/>
+          <p:cNvPr id="807643326" name="Rectangle 24"/>
           <p:cNvSpPr/>
           <p:nvPr userDrawn="1"/>
         </p:nvSpPr>
@@ -12237,7 +12237,7 @@
       </p:sp>
       <p:sp>
         <p:nvSpPr>
-          <p:cNvPr id="262288270" name="Rectangle 26"/>
+          <p:cNvPr id="1538027207" name="Rectangle 26"/>
           <p:cNvSpPr/>
           <p:nvPr userDrawn="1"/>
         </p:nvSpPr>
@@ -12261,7 +12261,7 @@
       </p:sp>
       <p:sp>
         <p:nvSpPr>
-          <p:cNvPr id="238666374" name="Rectangle 27"/>
+          <p:cNvPr id="1030598906" name="Rectangle 27"/>
           <p:cNvSpPr/>
           <p:nvPr userDrawn="1"/>
         </p:nvSpPr>
@@ -12285,7 +12285,7 @@
       </p:sp>
       <p:sp>
         <p:nvSpPr>
-          <p:cNvPr id="1328663636" name="Rectangle 28"/>
+          <p:cNvPr id="2010825508" name="Rectangle 28"/>
           <p:cNvSpPr/>
           <p:nvPr userDrawn="1"/>
         </p:nvSpPr>
@@ -12309,7 +12309,7 @@
       </p:sp>
       <p:sp>
         <p:nvSpPr>
-          <p:cNvPr id="686341552" name="Rectangle 25"/>
+          <p:cNvPr id="789021321" name="Rectangle 25"/>
           <p:cNvSpPr/>
           <p:nvPr userDrawn="1"/>
         </p:nvSpPr>
@@ -12333,7 +12333,7 @@
       </p:sp>
       <p:sp>
         <p:nvSpPr>
-          <p:cNvPr id="1518104577" name="Rectangle 20"/>
+          <p:cNvPr id="2097131088" name="Rectangle 20"/>
           <p:cNvSpPr/>
           <p:nvPr userDrawn="1"/>
         </p:nvSpPr>
@@ -12357,7 +12357,7 @@
       </p:sp>
       <p:sp>
         <p:nvSpPr>
-          <p:cNvPr id="774288061" name="Rectangle 43"/>
+          <p:cNvPr id="422658999" name="Rectangle 43"/>
           <p:cNvSpPr/>
           <p:nvPr userDrawn="1"/>
         </p:nvSpPr>
@@ -12381,7 +12381,7 @@
       </p:sp>
       <p:sp>
         <p:nvSpPr>
-          <p:cNvPr id="2004332968" name="Rectangle 45"/>
+          <p:cNvPr id="360181808" name="Rectangle 45"/>
           <p:cNvSpPr/>
           <p:nvPr userDrawn="1"/>
         </p:nvSpPr>
@@ -12405,7 +12405,7 @@
       </p:sp>
       <p:sp>
         <p:nvSpPr>
-          <p:cNvPr id="497266795" name="Rectangle 44"/>
+          <p:cNvPr id="46720747" name="Rectangle 44"/>
           <p:cNvSpPr/>
           <p:nvPr userDrawn="1"/>
         </p:nvSpPr>
@@ -12435,7 +12435,7 @@
       </p:sp>
       <p:sp>
         <p:nvSpPr>
-          <p:cNvPr id="597604476" name="Subtitle 2"/>
+          <p:cNvPr id="1543268432" name="Subtitle 2"/>
           <p:cNvSpPr>
             <a:spLocks noGrp="1"/>
           </p:cNvSpPr>
@@ -12559,7 +12559,7 @@
       </p:sp>
       <p:sp>
         <p:nvSpPr>
-          <p:cNvPr id="1387249485" name="Title 9"/>
+          <p:cNvPr id="1415336336" name="Title 9"/>
           <p:cNvSpPr>
             <a:spLocks noGrp="1"/>
           </p:cNvSpPr>
@@ -12602,7 +12602,7 @@
       </p:sp>
       <p:cxnSp>
         <p:nvCxnSpPr>
-          <p:cNvPr id="2117507024" name="Прямая соединительная линия 48"/>
+          <p:cNvPr id="1210503865" name="Прямая соединительная линия 48"/>
           <p:cNvCxnSpPr/>
           <p:nvPr userDrawn="1"/>
         </p:nvCxnSpPr>
@@ -12639,7 +12639,7 @@
       </p:cxnSp>
       <p:sp>
         <p:nvSpPr>
-          <p:cNvPr id="1175812686" name="Овал 50"/>
+          <p:cNvPr id="2059822624" name="Овал 50"/>
           <p:cNvSpPr/>
           <p:nvPr userDrawn="1"/>
         </p:nvSpPr>
@@ -12662,7 +12662,7 @@
       </p:sp>
       <p:cxnSp>
         <p:nvCxnSpPr>
-          <p:cNvPr id="1668880578" name="Прямая соединительная линия 53"/>
+          <p:cNvPr id="572592366" name="Прямая соединительная линия 53"/>
           <p:cNvCxnSpPr/>
           <p:nvPr userDrawn="1"/>
         </p:nvCxnSpPr>
@@ -12699,7 +12699,7 @@
       </p:cxnSp>
       <p:sp>
         <p:nvSpPr>
-          <p:cNvPr id="779292808" name="Date Placeholder 3"/>
+          <p:cNvPr id="1393870987" name="Date Placeholder 3"/>
           <p:cNvSpPr>
             <a:spLocks noGrp="1"/>
           </p:cNvSpPr>
@@ -12725,7 +12725,7 @@
       </p:sp>
       <p:sp>
         <p:nvSpPr>
-          <p:cNvPr id="1460402607" name="Footer Placeholder 4"/>
+          <p:cNvPr id="2105606146" name="Footer Placeholder 4"/>
           <p:cNvSpPr>
             <a:spLocks noGrp="1"/>
           </p:cNvSpPr>
@@ -12747,7 +12747,7 @@
       </p:sp>
       <p:sp>
         <p:nvSpPr>
-          <p:cNvPr id="1361886489" name="Slide Number Placeholder 5"/>
+          <p:cNvPr id="2092077623" name="Slide Number Placeholder 5"/>
           <p:cNvSpPr>
             <a:spLocks noGrp="1"/>
           </p:cNvSpPr>
@@ -12798,7 +12798,7 @@
       </p:grpSpPr>
       <p:sp>
         <p:nvSpPr>
-          <p:cNvPr id="49288774" name="Title 1"/>
+          <p:cNvPr id="948839851" name="Title 1"/>
           <p:cNvSpPr>
             <a:spLocks noGrp="1"/>
           </p:cNvSpPr>
@@ -12824,7 +12824,7 @@
       </p:sp>
       <p:sp>
         <p:nvSpPr>
-          <p:cNvPr id="1608812770" name="Content Placeholder 2"/>
+          <p:cNvPr id="1930825001" name="Content Placeholder 2"/>
           <p:cNvSpPr>
             <a:spLocks noGrp="1"/>
           </p:cNvSpPr>
@@ -12890,7 +12890,7 @@
       </p:sp>
       <p:sp>
         <p:nvSpPr>
-          <p:cNvPr id="197787449" name="Date Placeholder 3"/>
+          <p:cNvPr id="1141284359" name="Date Placeholder 3"/>
           <p:cNvSpPr>
             <a:spLocks noGrp="1"/>
           </p:cNvSpPr>
@@ -12916,7 +12916,7 @@
       </p:sp>
       <p:sp>
         <p:nvSpPr>
-          <p:cNvPr id="1195870036" name="Footer Placeholder 4"/>
+          <p:cNvPr id="474890717" name="Footer Placeholder 4"/>
           <p:cNvSpPr>
             <a:spLocks noGrp="1"/>
           </p:cNvSpPr>
@@ -12938,7 +12938,7 @@
       </p:sp>
       <p:sp>
         <p:nvSpPr>
-          <p:cNvPr id="1593607194" name="Slide Number Placeholder 5"/>
+          <p:cNvPr id="319182077" name="Slide Number Placeholder 5"/>
           <p:cNvSpPr>
             <a:spLocks noGrp="1"/>
           </p:cNvSpPr>
@@ -12989,7 +12989,7 @@
       </p:grpSpPr>
       <p:sp>
         <p:nvSpPr>
-          <p:cNvPr id="2047400704" name="Text Placeholder 2"/>
+          <p:cNvPr id="1847135819" name="Text Placeholder 2"/>
           <p:cNvSpPr>
             <a:spLocks noGrp="1"/>
           </p:cNvSpPr>
@@ -13111,7 +13111,7 @@
       </p:sp>
       <p:sp>
         <p:nvSpPr>
-          <p:cNvPr id="258280587" name="Date Placeholder 3"/>
+          <p:cNvPr id="2145263779" name="Date Placeholder 3"/>
           <p:cNvSpPr>
             <a:spLocks noGrp="1"/>
           </p:cNvSpPr>
@@ -13137,7 +13137,7 @@
       </p:sp>
       <p:sp>
         <p:nvSpPr>
-          <p:cNvPr id="180988522" name="Footer Placeholder 4"/>
+          <p:cNvPr id="19940881" name="Footer Placeholder 4"/>
           <p:cNvSpPr>
             <a:spLocks noGrp="1"/>
           </p:cNvSpPr>
@@ -13159,7 +13159,7 @@
       </p:sp>
       <p:sp>
         <p:nvSpPr>
-          <p:cNvPr id="854801104" name="Slide Number Placeholder 5"/>
+          <p:cNvPr id="99974807" name="Slide Number Placeholder 5"/>
           <p:cNvSpPr>
             <a:spLocks noGrp="1"/>
           </p:cNvSpPr>
@@ -13185,7 +13185,7 @@
       </p:sp>
       <p:sp>
         <p:nvSpPr>
-          <p:cNvPr id="613296147" name="Title 1"/>
+          <p:cNvPr id="1637547902" name="Title 1"/>
           <p:cNvSpPr>
             <a:spLocks noGrp="1"/>
           </p:cNvSpPr>
@@ -13241,7 +13241,7 @@
       </p:grpSpPr>
       <p:sp>
         <p:nvSpPr>
-          <p:cNvPr id="447900239" name="Title 1"/>
+          <p:cNvPr id="1575994554" name="Title 1"/>
           <p:cNvSpPr>
             <a:spLocks noGrp="1"/>
           </p:cNvSpPr>
@@ -13267,7 +13267,7 @@
       </p:sp>
       <p:sp>
         <p:nvSpPr>
-          <p:cNvPr id="1442602874" name="Content Placeholder 2"/>
+          <p:cNvPr id="1701799446" name="Content Placeholder 2"/>
           <p:cNvSpPr>
             <a:spLocks noGrp="1"/>
           </p:cNvSpPr>
@@ -13370,7 +13370,7 @@
       </p:sp>
       <p:sp>
         <p:nvSpPr>
-          <p:cNvPr id="390212427" name="Content Placeholder 3"/>
+          <p:cNvPr id="2133935890" name="Content Placeholder 3"/>
           <p:cNvSpPr>
             <a:spLocks noGrp="1"/>
           </p:cNvSpPr>
@@ -13473,7 +13473,7 @@
       </p:sp>
       <p:sp>
         <p:nvSpPr>
-          <p:cNvPr id="1631375455" name="Date Placeholder 4"/>
+          <p:cNvPr id="153463314" name="Date Placeholder 4"/>
           <p:cNvSpPr>
             <a:spLocks noGrp="1"/>
           </p:cNvSpPr>
@@ -13499,7 +13499,7 @@
       </p:sp>
       <p:sp>
         <p:nvSpPr>
-          <p:cNvPr id="1968637747" name="Footer Placeholder 5"/>
+          <p:cNvPr id="1675764665" name="Footer Placeholder 5"/>
           <p:cNvSpPr>
             <a:spLocks noGrp="1"/>
           </p:cNvSpPr>
@@ -13521,7 +13521,7 @@
       </p:sp>
       <p:sp>
         <p:nvSpPr>
-          <p:cNvPr id="431513927" name="Slide Number Placeholder 6"/>
+          <p:cNvPr id="1679591128" name="Slide Number Placeholder 6"/>
           <p:cNvSpPr>
             <a:spLocks noGrp="1"/>
           </p:cNvSpPr>
@@ -13572,7 +13572,7 @@
       </p:grpSpPr>
       <p:sp>
         <p:nvSpPr>
-          <p:cNvPr id="1616637041" name="Title 1"/>
+          <p:cNvPr id="1738998835" name="Title 1"/>
           <p:cNvSpPr>
             <a:spLocks noGrp="1"/>
           </p:cNvSpPr>
@@ -13602,7 +13602,7 @@
       </p:sp>
       <p:sp>
         <p:nvSpPr>
-          <p:cNvPr id="370264459" name="Text Placeholder 2"/>
+          <p:cNvPr id="1196766879" name="Text Placeholder 2"/>
           <p:cNvSpPr>
             <a:spLocks noGrp="1"/>
           </p:cNvSpPr>
@@ -13674,7 +13674,7 @@
       </p:sp>
       <p:sp>
         <p:nvSpPr>
-          <p:cNvPr id="1213442202" name="Content Placeholder 3"/>
+          <p:cNvPr id="1967073737" name="Content Placeholder 3"/>
           <p:cNvSpPr>
             <a:spLocks noGrp="1"/>
           </p:cNvSpPr>
@@ -13777,7 +13777,7 @@
       </p:sp>
       <p:sp>
         <p:nvSpPr>
-          <p:cNvPr id="548991665" name="Text Placeholder 4"/>
+          <p:cNvPr id="1423978176" name="Text Placeholder 4"/>
           <p:cNvSpPr>
             <a:spLocks noGrp="1"/>
           </p:cNvSpPr>
@@ -13849,7 +13849,7 @@
       </p:sp>
       <p:sp>
         <p:nvSpPr>
-          <p:cNvPr id="2103816608" name="Content Placeholder 5"/>
+          <p:cNvPr id="1824182280" name="Content Placeholder 5"/>
           <p:cNvSpPr>
             <a:spLocks noGrp="1"/>
           </p:cNvSpPr>
@@ -13952,7 +13952,7 @@
       </p:sp>
       <p:sp>
         <p:nvSpPr>
-          <p:cNvPr id="1350443006" name="Date Placeholder 6"/>
+          <p:cNvPr id="1112722290" name="Date Placeholder 6"/>
           <p:cNvSpPr>
             <a:spLocks noGrp="1"/>
           </p:cNvSpPr>
@@ -13978,7 +13978,7 @@
       </p:sp>
       <p:sp>
         <p:nvSpPr>
-          <p:cNvPr id="303345093" name="Footer Placeholder 7"/>
+          <p:cNvPr id="1361033468" name="Footer Placeholder 7"/>
           <p:cNvSpPr>
             <a:spLocks noGrp="1"/>
           </p:cNvSpPr>
@@ -14000,7 +14000,7 @@
       </p:sp>
       <p:sp>
         <p:nvSpPr>
-          <p:cNvPr id="1011119318" name="Slide Number Placeholder 8"/>
+          <p:cNvPr id="1116615433" name="Slide Number Placeholder 8"/>
           <p:cNvSpPr>
             <a:spLocks noGrp="1"/>
           </p:cNvSpPr>
@@ -14051,7 +14051,7 @@
       </p:grpSpPr>
       <p:sp>
         <p:nvSpPr>
-          <p:cNvPr id="860786533" name="Title 1"/>
+          <p:cNvPr id="1608298259" name="Title 1"/>
           <p:cNvSpPr>
             <a:spLocks noGrp="1"/>
           </p:cNvSpPr>
@@ -14077,7 +14077,7 @@
       </p:sp>
       <p:sp>
         <p:nvSpPr>
-          <p:cNvPr id="44981526" name="Date Placeholder 2"/>
+          <p:cNvPr id="1266117154" name="Date Placeholder 2"/>
           <p:cNvSpPr>
             <a:spLocks noGrp="1"/>
           </p:cNvSpPr>
@@ -14103,7 +14103,7 @@
       </p:sp>
       <p:sp>
         <p:nvSpPr>
-          <p:cNvPr id="487172176" name="Footer Placeholder 3"/>
+          <p:cNvPr id="313256467" name="Footer Placeholder 3"/>
           <p:cNvSpPr>
             <a:spLocks noGrp="1"/>
           </p:cNvSpPr>
@@ -14125,7 +14125,7 @@
       </p:sp>
       <p:sp>
         <p:nvSpPr>
-          <p:cNvPr id="562898082" name="Slide Number Placeholder 4"/>
+          <p:cNvPr id="1057156642" name="Slide Number Placeholder 4"/>
           <p:cNvSpPr>
             <a:spLocks noGrp="1"/>
           </p:cNvSpPr>
@@ -14176,7 +14176,7 @@
       </p:grpSpPr>
       <p:sp>
         <p:nvSpPr>
-          <p:cNvPr id="568532543" name="Date Placeholder 1"/>
+          <p:cNvPr id="1532849860" name="Date Placeholder 1"/>
           <p:cNvSpPr>
             <a:spLocks noGrp="1"/>
           </p:cNvSpPr>
@@ -14202,7 +14202,7 @@
       </p:sp>
       <p:sp>
         <p:nvSpPr>
-          <p:cNvPr id="133092210" name="Footer Placeholder 2"/>
+          <p:cNvPr id="1654221991" name="Footer Placeholder 2"/>
           <p:cNvSpPr>
             <a:spLocks noGrp="1"/>
           </p:cNvSpPr>
@@ -14224,7 +14224,7 @@
       </p:sp>
       <p:sp>
         <p:nvSpPr>
-          <p:cNvPr id="260635479" name="Slide Number Placeholder 3"/>
+          <p:cNvPr id="943530503" name="Slide Number Placeholder 3"/>
           <p:cNvSpPr>
             <a:spLocks noGrp="1"/>
           </p:cNvSpPr>
@@ -14275,7 +14275,7 @@
       </p:grpSpPr>
       <p:sp>
         <p:nvSpPr>
-          <p:cNvPr id="856119691" name="Content Placeholder 2"/>
+          <p:cNvPr id="829467757" name="Content Placeholder 2"/>
           <p:cNvSpPr>
             <a:spLocks noGrp="1"/>
           </p:cNvSpPr>
@@ -14380,7 +14380,7 @@
       </p:sp>
       <p:sp>
         <p:nvSpPr>
-          <p:cNvPr id="1874879304" name="Text Placeholder 3"/>
+          <p:cNvPr id="2125849733" name="Text Placeholder 3"/>
           <p:cNvSpPr>
             <a:spLocks noGrp="1"/>
           </p:cNvSpPr>
@@ -14454,7 +14454,7 @@
       </p:sp>
       <p:sp>
         <p:nvSpPr>
-          <p:cNvPr id="1324902754" name="Date Placeholder 4"/>
+          <p:cNvPr id="1605724325" name="Date Placeholder 4"/>
           <p:cNvSpPr>
             <a:spLocks noGrp="1"/>
           </p:cNvSpPr>
@@ -14480,7 +14480,7 @@
       </p:sp>
       <p:sp>
         <p:nvSpPr>
-          <p:cNvPr id="350500463" name="Footer Placeholder 5"/>
+          <p:cNvPr id="515524672" name="Footer Placeholder 5"/>
           <p:cNvSpPr>
             <a:spLocks noGrp="1"/>
           </p:cNvSpPr>
@@ -14502,7 +14502,7 @@
       </p:sp>
       <p:sp>
         <p:nvSpPr>
-          <p:cNvPr id="996581458" name="Slide Number Placeholder 6"/>
+          <p:cNvPr id="385376143" name="Slide Number Placeholder 6"/>
           <p:cNvSpPr>
             <a:spLocks noGrp="1"/>
           </p:cNvSpPr>
@@ -14528,7 +14528,7 @@
       </p:sp>
       <p:sp>
         <p:nvSpPr>
-          <p:cNvPr id="1345637219" name="Title 1"/>
+          <p:cNvPr id="569492319" name="Title 1"/>
           <p:cNvSpPr>
             <a:spLocks noGrp="1"/>
           </p:cNvSpPr>
@@ -14584,7 +14584,7 @@
       </p:grpSpPr>
       <p:sp>
         <p:nvSpPr>
-          <p:cNvPr id="1072560962" name="Picture Placeholder 2"/>
+          <p:cNvPr id="913414721" name="Picture Placeholder 2"/>
           <p:cNvSpPr>
             <a:spLocks noGrp="1"/>
           </p:cNvSpPr>
@@ -14652,7 +14652,7 @@
       </p:sp>
       <p:sp>
         <p:nvSpPr>
-          <p:cNvPr id="1795096908" name="Text Placeholder 3"/>
+          <p:cNvPr id="224303150" name="Text Placeholder 3"/>
           <p:cNvSpPr>
             <a:spLocks noGrp="1"/>
           </p:cNvSpPr>
@@ -14720,7 +14720,7 @@
       </p:sp>
       <p:sp>
         <p:nvSpPr>
-          <p:cNvPr id="1981549285" name="Date Placeholder 4"/>
+          <p:cNvPr id="839492790" name="Date Placeholder 4"/>
           <p:cNvSpPr>
             <a:spLocks noGrp="1"/>
           </p:cNvSpPr>
@@ -14746,7 +14746,7 @@
       </p:sp>
       <p:sp>
         <p:nvSpPr>
-          <p:cNvPr id="127441459" name="Footer Placeholder 5"/>
+          <p:cNvPr id="1177779915" name="Footer Placeholder 5"/>
           <p:cNvSpPr>
             <a:spLocks noGrp="1"/>
           </p:cNvSpPr>
@@ -14768,7 +14768,7 @@
       </p:sp>
       <p:sp>
         <p:nvSpPr>
-          <p:cNvPr id="1385756202" name="Slide Number Placeholder 6"/>
+          <p:cNvPr id="579925987" name="Slide Number Placeholder 6"/>
           <p:cNvSpPr>
             <a:spLocks noGrp="1"/>
           </p:cNvSpPr>
@@ -14794,7 +14794,7 @@
       </p:sp>
       <p:sp>
         <p:nvSpPr>
-          <p:cNvPr id="1770042341" name="Title 1"/>
+          <p:cNvPr id="1576580823" name="Title 1"/>
           <p:cNvSpPr>
             <a:spLocks noGrp="1"/>
           </p:cNvSpPr>
@@ -14850,7 +14850,7 @@
       </p:grpSpPr>
       <p:sp>
         <p:nvSpPr>
-          <p:cNvPr id="251153798" name="Google Shape;25;p54"/>
+          <p:cNvPr id="1890731708" name="Google Shape;25;p54"/>
           <p:cNvSpPr txBox="1">
             <a:spLocks noGrp="1"/>
           </p:cNvSpPr>
@@ -15013,7 +15013,7 @@
       </p:sp>
       <p:sp>
         <p:nvSpPr>
-          <p:cNvPr id="2079024127" name="Google Shape;26;p54"/>
+          <p:cNvPr id="726463193" name="Google Shape;26;p54"/>
           <p:cNvSpPr txBox="1">
             <a:spLocks noGrp="1"/>
           </p:cNvSpPr>
@@ -15176,7 +15176,7 @@
       </p:sp>
       <p:sp>
         <p:nvSpPr>
-          <p:cNvPr id="499258516" name="Google Shape;27;p54"/>
+          <p:cNvPr id="515850938" name="Google Shape;27;p54"/>
           <p:cNvSpPr txBox="1">
             <a:spLocks noGrp="1"/>
           </p:cNvSpPr>
@@ -15474,7 +15474,7 @@
       </p:grpSpPr>
       <p:sp>
         <p:nvSpPr>
-          <p:cNvPr id="199312576" name="Title 1"/>
+          <p:cNvPr id="408090621" name="Title 1"/>
           <p:cNvSpPr>
             <a:spLocks noGrp="1"/>
           </p:cNvSpPr>
@@ -15500,7 +15500,7 @@
       </p:sp>
       <p:sp>
         <p:nvSpPr>
-          <p:cNvPr id="1949160892" name="Vertical Text Placeholder 2"/>
+          <p:cNvPr id="1111336887" name="Vertical Text Placeholder 2"/>
           <p:cNvSpPr>
             <a:spLocks noGrp="1"/>
           </p:cNvSpPr>
@@ -15566,7 +15566,7 @@
       </p:sp>
       <p:sp>
         <p:nvSpPr>
-          <p:cNvPr id="1790451729" name="Date Placeholder 3"/>
+          <p:cNvPr id="542602217" name="Date Placeholder 3"/>
           <p:cNvSpPr>
             <a:spLocks noGrp="1"/>
           </p:cNvSpPr>
@@ -15592,7 +15592,7 @@
       </p:sp>
       <p:sp>
         <p:nvSpPr>
-          <p:cNvPr id="1684242734" name="Footer Placeholder 4"/>
+          <p:cNvPr id="1299667975" name="Footer Placeholder 4"/>
           <p:cNvSpPr>
             <a:spLocks noGrp="1"/>
           </p:cNvSpPr>
@@ -15614,7 +15614,7 @@
       </p:sp>
       <p:sp>
         <p:nvSpPr>
-          <p:cNvPr id="2045255525" name="Slide Number Placeholder 5"/>
+          <p:cNvPr id="173313212" name="Slide Number Placeholder 5"/>
           <p:cNvSpPr>
             <a:spLocks noGrp="1"/>
           </p:cNvSpPr>
@@ -15665,7 +15665,7 @@
       </p:grpSpPr>
       <p:sp>
         <p:nvSpPr>
-          <p:cNvPr id="417067076" name="Vertical Title 1"/>
+          <p:cNvPr id="481728471" name="Vertical Title 1"/>
           <p:cNvSpPr>
             <a:spLocks noGrp="1"/>
           </p:cNvSpPr>
@@ -15696,7 +15696,7 @@
       </p:sp>
       <p:sp>
         <p:nvSpPr>
-          <p:cNvPr id="801029918" name="Vertical Text Placeholder 2"/>
+          <p:cNvPr id="330658249" name="Vertical Text Placeholder 2"/>
           <p:cNvSpPr>
             <a:spLocks noGrp="1"/>
           </p:cNvSpPr>
@@ -15767,7 +15767,7 @@
       </p:sp>
       <p:sp>
         <p:nvSpPr>
-          <p:cNvPr id="1702456753" name="Date Placeholder 3"/>
+          <p:cNvPr id="1901860068" name="Date Placeholder 3"/>
           <p:cNvSpPr>
             <a:spLocks noGrp="1"/>
           </p:cNvSpPr>
@@ -15793,7 +15793,7 @@
       </p:sp>
       <p:sp>
         <p:nvSpPr>
-          <p:cNvPr id="1475365091" name="Footer Placeholder 4"/>
+          <p:cNvPr id="172454077" name="Footer Placeholder 4"/>
           <p:cNvSpPr>
             <a:spLocks noGrp="1"/>
           </p:cNvSpPr>
@@ -15815,7 +15815,7 @@
       </p:sp>
       <p:sp>
         <p:nvSpPr>
-          <p:cNvPr id="1253693141" name="Slide Number Placeholder 5"/>
+          <p:cNvPr id="1821465418" name="Slide Number Placeholder 5"/>
           <p:cNvSpPr>
             <a:spLocks noGrp="1"/>
           </p:cNvSpPr>
@@ -15866,7 +15866,7 @@
       </p:grpSpPr>
       <p:sp>
         <p:nvSpPr>
-          <p:cNvPr id="1026571299" name="Google Shape;29;p55"/>
+          <p:cNvPr id="252890549" name="Google Shape;29;p55"/>
           <p:cNvSpPr txBox="1">
             <a:spLocks noGrp="1"/>
           </p:cNvSpPr>
@@ -16029,7 +16029,7 @@
       </p:sp>
       <p:sp>
         <p:nvSpPr>
-          <p:cNvPr id="81913299" name="Google Shape;30;p55"/>
+          <p:cNvPr id="1983479053" name="Google Shape;30;p55"/>
           <p:cNvSpPr txBox="1">
             <a:spLocks noGrp="1"/>
           </p:cNvSpPr>
@@ -16192,7 +16192,7 @@
       </p:sp>
       <p:sp>
         <p:nvSpPr>
-          <p:cNvPr id="509467126" name="Google Shape;31;p55"/>
+          <p:cNvPr id="1818829899" name="Google Shape;31;p55"/>
           <p:cNvSpPr txBox="1">
             <a:spLocks noGrp="1"/>
           </p:cNvSpPr>
@@ -16490,7 +16490,7 @@
       </p:grpSpPr>
       <p:sp>
         <p:nvSpPr>
-          <p:cNvPr id="1864805616" name="Google Shape;33;p56"/>
+          <p:cNvPr id="2081834268" name="Google Shape;33;p56"/>
           <p:cNvSpPr txBox="1">
             <a:spLocks noGrp="1"/>
           </p:cNvSpPr>
@@ -16653,7 +16653,7 @@
       </p:sp>
       <p:sp>
         <p:nvSpPr>
-          <p:cNvPr id="1011589951" name="Google Shape;34;p56"/>
+          <p:cNvPr id="1951167221" name="Google Shape;34;p56"/>
           <p:cNvSpPr txBox="1">
             <a:spLocks noGrp="1"/>
           </p:cNvSpPr>
@@ -16816,7 +16816,7 @@
       </p:sp>
       <p:sp>
         <p:nvSpPr>
-          <p:cNvPr id="755178914" name="Google Shape;35;p56"/>
+          <p:cNvPr id="797981508" name="Google Shape;35;p56"/>
           <p:cNvSpPr txBox="1"/>
           <p:nvPr/>
         </p:nvSpPr>
@@ -16881,7 +16881,7 @@
       </p:sp>
       <p:sp>
         <p:nvSpPr>
-          <p:cNvPr id="904057741" name="Google Shape;36;p56"/>
+          <p:cNvPr id="106865506" name="Google Shape;36;p56"/>
           <p:cNvSpPr txBox="1">
             <a:spLocks noGrp="1"/>
           </p:cNvSpPr>
@@ -17186,7 +17186,7 @@
       </p:grpSpPr>
       <p:sp>
         <p:nvSpPr>
-          <p:cNvPr id="695419819" name="Google Shape;38;p57"/>
+          <p:cNvPr id="1687481024" name="Google Shape;38;p57"/>
           <p:cNvSpPr txBox="1">
             <a:spLocks noGrp="1"/>
           </p:cNvSpPr>
@@ -17349,7 +17349,7 @@
       </p:sp>
       <p:sp>
         <p:nvSpPr>
-          <p:cNvPr id="38895071" name="Google Shape;39;p57"/>
+          <p:cNvPr id="1226002502" name="Google Shape;39;p57"/>
           <p:cNvSpPr txBox="1">
             <a:spLocks noGrp="1"/>
           </p:cNvSpPr>
@@ -17654,7 +17654,7 @@
       </p:grpSpPr>
       <p:sp>
         <p:nvSpPr>
-          <p:cNvPr id="1091227540" name="Google Shape;41;p58"/>
+          <p:cNvPr id="1197728578" name="Google Shape;41;p58"/>
           <p:cNvSpPr txBox="1">
             <a:spLocks noGrp="1"/>
           </p:cNvSpPr>
@@ -17705,7 +17705,7 @@
       </p:sp>
       <p:sp>
         <p:nvSpPr>
-          <p:cNvPr id="381599416" name="Google Shape;42;p58"/>
+          <p:cNvPr id="882044076" name="Google Shape;42;p58"/>
           <p:cNvSpPr txBox="1">
             <a:spLocks noGrp="1"/>
           </p:cNvSpPr>
@@ -18010,7 +18010,7 @@
       </p:grpSpPr>
       <p:sp>
         <p:nvSpPr>
-          <p:cNvPr id="480854483" name="Google Shape;44;p59"/>
+          <p:cNvPr id="1332641542" name="Google Shape;44;p59"/>
           <p:cNvSpPr txBox="1">
             <a:spLocks noGrp="1"/>
           </p:cNvSpPr>
@@ -18315,7 +18315,7 @@
       </p:grpSpPr>
       <p:sp>
         <p:nvSpPr>
-          <p:cNvPr id="713583865" name="Google Shape;6;p49"/>
+          <p:cNvPr id="1785285674" name="Google Shape;6;p49"/>
           <p:cNvSpPr txBox="1">
             <a:spLocks noGrp="1"/>
           </p:cNvSpPr>
@@ -18577,7 +18577,7 @@
       </p:sp>
       <p:sp>
         <p:nvSpPr>
-          <p:cNvPr id="1822178821" name="Google Shape;7;p49"/>
+          <p:cNvPr id="1080295328" name="Google Shape;7;p49"/>
           <p:cNvSpPr txBox="1">
             <a:spLocks noGrp="1"/>
           </p:cNvSpPr>
@@ -18839,7 +18839,7 @@
       </p:sp>
       <p:sp>
         <p:nvSpPr>
-          <p:cNvPr id="1195816437" name="Google Shape;8;p49"/>
+          <p:cNvPr id="1538575915" name="Google Shape;8;p49"/>
           <p:cNvSpPr txBox="1">
             <a:spLocks noGrp="1"/>
           </p:cNvSpPr>
@@ -19817,7 +19817,7 @@
       </p:grpSpPr>
       <p:sp>
         <p:nvSpPr>
-          <p:cNvPr id="388192635" name="Google Shape;51;g320ca67c64f_0_409"/>
+          <p:cNvPr id="1661890472" name="Google Shape;51;g320ca67c64f_0_409"/>
           <p:cNvSpPr txBox="1">
             <a:spLocks noGrp="1"/>
           </p:cNvSpPr>
@@ -20052,7 +20052,7 @@
       </p:sp>
       <p:sp>
         <p:nvSpPr>
-          <p:cNvPr id="1693312271" name="Google Shape;52;g320ca67c64f_0_409"/>
+          <p:cNvPr id="1520620095" name="Google Shape;52;g320ca67c64f_0_409"/>
           <p:cNvSpPr txBox="1">
             <a:spLocks noGrp="1"/>
           </p:cNvSpPr>
@@ -20314,7 +20314,7 @@
       </p:sp>
       <p:sp>
         <p:nvSpPr>
-          <p:cNvPr id="636855955" name="Google Shape;53;g320ca67c64f_0_409"/>
+          <p:cNvPr id="535269107" name="Google Shape;53;g320ca67c64f_0_409"/>
           <p:cNvSpPr txBox="1">
             <a:spLocks noGrp="1"/>
           </p:cNvSpPr>
@@ -21166,7 +21166,7 @@
       </p:grpSpPr>
       <p:sp>
         <p:nvSpPr>
-          <p:cNvPr id="1008179638" name="Google Shape;6;p1"/>
+          <p:cNvPr id="253378306" name="Google Shape;6;p1"/>
           <p:cNvSpPr txBox="1">
             <a:spLocks noGrp="1"/>
           </p:cNvSpPr>
@@ -21401,7 +21401,7 @@
       </p:sp>
       <p:sp>
         <p:nvSpPr>
-          <p:cNvPr id="1411344583" name="Google Shape;7;p1"/>
+          <p:cNvPr id="1625863831" name="Google Shape;7;p1"/>
           <p:cNvSpPr txBox="1">
             <a:spLocks noGrp="1"/>
           </p:cNvSpPr>
@@ -21663,7 +21663,7 @@
       </p:sp>
       <p:sp>
         <p:nvSpPr>
-          <p:cNvPr id="1179314536" name="Google Shape;8;p1"/>
+          <p:cNvPr id="716690046" name="Google Shape;8;p1"/>
           <p:cNvSpPr txBox="1">
             <a:spLocks noGrp="1"/>
           </p:cNvSpPr>
@@ -22518,7 +22518,7 @@
       </p:grpSpPr>
       <p:sp>
         <p:nvSpPr>
-          <p:cNvPr id="2110166860" name="Title Placeholder 1"/>
+          <p:cNvPr id="1656263693" name="Title Placeholder 1"/>
           <p:cNvSpPr>
             <a:spLocks noGrp="1"/>
           </p:cNvSpPr>
@@ -22550,7 +22550,7 @@
       </p:sp>
       <p:sp>
         <p:nvSpPr>
-          <p:cNvPr id="191885701" name="Text Placeholder 2"/>
+          <p:cNvPr id="183818244" name="Text Placeholder 2"/>
           <p:cNvSpPr>
             <a:spLocks noGrp="1"/>
           </p:cNvSpPr>
@@ -22631,7 +22631,7 @@
       </p:sp>
       <p:sp>
         <p:nvSpPr>
-          <p:cNvPr id="997870648" name="Date Placeholder 3"/>
+          <p:cNvPr id="342424932" name="Date Placeholder 3"/>
           <p:cNvSpPr>
             <a:spLocks noGrp="1"/>
           </p:cNvSpPr>
@@ -22673,7 +22673,7 @@
       </p:sp>
       <p:sp>
         <p:nvSpPr>
-          <p:cNvPr id="1157480165" name="Footer Placeholder 4"/>
+          <p:cNvPr id="878622540" name="Footer Placeholder 4"/>
           <p:cNvSpPr>
             <a:spLocks noGrp="1"/>
           </p:cNvSpPr>
@@ -22711,7 +22711,7 @@
       </p:sp>
       <p:sp>
         <p:nvSpPr>
-          <p:cNvPr id="54513013" name="Slide Number Placeholder 8"/>
+          <p:cNvPr id="313473290" name="Slide Number Placeholder 8"/>
           <p:cNvSpPr>
             <a:spLocks noGrp="1"/>
           </p:cNvSpPr>
@@ -23085,7 +23085,7 @@
       </p:grpSpPr>
       <p:sp>
         <p:nvSpPr>
-          <p:cNvPr id="1222406587" name="Google Shape;107;p2"/>
+          <p:cNvPr id="493174346" name="Google Shape;107;p2"/>
           <p:cNvSpPr txBox="1">
             <a:spLocks noGrp="1"/>
           </p:cNvSpPr>
@@ -23150,7 +23150,7 @@
       </p:sp>
       <p:sp>
         <p:nvSpPr>
-          <p:cNvPr id="1088938879" name="Google Shape;108;p2"/>
+          <p:cNvPr id="1498260574" name="Google Shape;108;p2"/>
           <p:cNvSpPr txBox="1">
             <a:spLocks noGrp="1"/>
           </p:cNvSpPr>
@@ -23201,7 +23201,7 @@
       </p:sp>
       <p:pic>
         <p:nvPicPr>
-          <p:cNvPr id="1936738844" name="Google Shape;109;p2" title="Logo for &quot;Cascadia College, in Bothell&quot;"/>
+          <p:cNvPr id="1860734032" name="Google Shape;109;p2" descr="Logo for &quot;Cascadia College, in Bothell&quot;" title="Logo for &quot;Cascadia College, in Bothell&quot;"/>
           <p:cNvPicPr/>
           <p:nvPr/>
         </p:nvPicPr>
@@ -23227,7 +23227,7 @@
       </p:pic>
       <p:pic>
         <p:nvPicPr>
-          <p:cNvPr id="1604689749" name="Logo for the Java programming language" title="Logo for the Java programming language"/>
+          <p:cNvPr id="126230612" name="Logo for the Java programming language" descr="Logo for the Java programming language" title="Logo for the Java programming language"/>
           <p:cNvPicPr/>
           <p:nvPr/>
         </p:nvPicPr>
@@ -23253,7 +23253,7 @@
       </p:pic>
       <p:sp>
         <p:nvSpPr>
-          <p:cNvPr id="1419986685" name="Google Shape;111;p2"/>
+          <p:cNvPr id="2059916874" name="Google Shape;111;p2"/>
           <p:cNvSpPr txBox="1">
             <a:spLocks noGrp="1"/>
           </p:cNvSpPr>
@@ -23337,7 +23337,7 @@
       </p:grpSpPr>
       <p:sp>
         <p:nvSpPr>
-          <p:cNvPr id="1043404583" name="Title 1"/>
+          <p:cNvPr id="309156581" name="Title 1"/>
           <p:cNvSpPr>
             <a:spLocks noGrp="1"/>
           </p:cNvSpPr>
@@ -23368,7 +23368,7 @@
       </p:sp>
       <p:sp>
         <p:nvSpPr>
-          <p:cNvPr id="1149370660" name="Text Placeholder 2"/>
+          <p:cNvPr id="719172185" name="Text Placeholder 2"/>
           <p:cNvSpPr>
             <a:spLocks noGrp="1"/>
           </p:cNvSpPr>
@@ -23436,7 +23436,7 @@
       </p:sp>
       <p:sp>
         <p:nvSpPr>
-          <p:cNvPr id="920031269" name="Slide Number Placeholder 3"/>
+          <p:cNvPr id="2087128941" name="Slide Number Placeholder 3"/>
           <p:cNvSpPr>
             <a:spLocks noGrp="1"/>
           </p:cNvSpPr>
@@ -23509,7 +23509,7 @@
       </p:grpSpPr>
       <p:sp>
         <p:nvSpPr>
-          <p:cNvPr id="395897019" name="Google Shape;515;g32a7fc5f463_1_0"/>
+          <p:cNvPr id="2062282319" name="Google Shape;515;g32a7fc5f463_1_0"/>
           <p:cNvSpPr txBox="1">
             <a:spLocks noGrp="1"/>
           </p:cNvSpPr>
@@ -23560,7 +23560,7 @@
       </p:sp>
       <p:sp>
         <p:nvSpPr>
-          <p:cNvPr id="1134723793" name="Google Shape;516;g32a7fc5f463_1_0"/>
+          <p:cNvPr id="1166901506" name="Google Shape;516;g32a7fc5f463_1_0"/>
           <p:cNvSpPr txBox="1">
             <a:spLocks noGrp="1"/>
           </p:cNvSpPr>
@@ -23797,7 +23797,7 @@
       </p:sp>
       <p:sp>
         <p:nvSpPr>
-          <p:cNvPr id="1021483716" name="Google Shape;517;g32a7fc5f463_1_0"/>
+          <p:cNvPr id="1572659985" name="Google Shape;517;g32a7fc5f463_1_0"/>
           <p:cNvSpPr txBox="1">
             <a:spLocks noGrp="1"/>
           </p:cNvSpPr>
@@ -23849,7 +23849,7 @@
       </p:sp>
       <p:pic>
         <p:nvPicPr>
-          <p:cNvPr id="275894991" name="Google Shape;518;g32a7fc5f463_1_0" title="Decorative image of adorable animal saying &quot;Bye Bye&quot;"/>
+          <p:cNvPr id="2104993391" name="Google Shape;518;g32a7fc5f463_1_0" descr="Decorative image of adorable animal saying &quot;Bye Bye&quot;" title="Decorative image of adorable animal saying &quot;Bye Bye&quot;"/>
           <p:cNvPicPr/>
           <p:nvPr/>
         </p:nvPicPr>
@@ -23908,7 +23908,7 @@
       </p:grpSpPr>
       <p:sp>
         <p:nvSpPr>
-          <p:cNvPr id="1434141494" name="Google Shape;128;p4"/>
+          <p:cNvPr id="1377745746" name="Google Shape;128;p4"/>
           <p:cNvSpPr txBox="1">
             <a:spLocks noGrp="1"/>
           </p:cNvSpPr>
@@ -23959,7 +23959,7 @@
       </p:sp>
       <p:sp>
         <p:nvSpPr>
-          <p:cNvPr id="416513614" name="Google Shape;129;p4"/>
+          <p:cNvPr id="930134212" name="Google Shape;129;p4"/>
           <p:cNvSpPr txBox="1">
             <a:spLocks noGrp="1"/>
           </p:cNvSpPr>
@@ -24153,7 +24153,7 @@
       </p:sp>
       <p:sp>
         <p:nvSpPr>
-          <p:cNvPr id="942103551" name="Google Shape;130;p4"/>
+          <p:cNvPr id="752645093" name="Google Shape;130;p4"/>
           <p:cNvSpPr txBox="1">
             <a:spLocks noGrp="1"/>
           </p:cNvSpPr>
@@ -24237,7 +24237,7 @@
       </p:grpSpPr>
       <p:sp>
         <p:nvSpPr>
-          <p:cNvPr id="630634770" name="Google Shape;135;p5"/>
+          <p:cNvPr id="547525302" name="Google Shape;135;p5"/>
           <p:cNvSpPr txBox="1">
             <a:spLocks noGrp="1"/>
           </p:cNvSpPr>
@@ -24288,7 +24288,7 @@
       </p:sp>
       <p:sp>
         <p:nvSpPr>
-          <p:cNvPr id="451334767" name="Google Shape;136;p5"/>
+          <p:cNvPr id="1958905574" name="Google Shape;136;p5"/>
           <p:cNvSpPr txBox="1">
             <a:spLocks noGrp="1"/>
           </p:cNvSpPr>
@@ -24536,7 +24536,7 @@
       </p:sp>
       <p:sp>
         <p:nvSpPr>
-          <p:cNvPr id="1717231776" name="Google Shape;137;p5"/>
+          <p:cNvPr id="1796625816" name="Google Shape;137;p5"/>
           <p:cNvSpPr txBox="1">
             <a:spLocks noGrp="1"/>
           </p:cNvSpPr>
@@ -24620,7 +24620,7 @@
       </p:grpSpPr>
       <p:sp>
         <p:nvSpPr>
-          <p:cNvPr id="1363611980" name="Google Shape;143;p6"/>
+          <p:cNvPr id="1178489882" name="Google Shape;143;p6"/>
           <p:cNvSpPr txBox="1">
             <a:spLocks noGrp="1"/>
           </p:cNvSpPr>
@@ -24671,7 +24671,7 @@
       </p:sp>
       <p:sp>
         <p:nvSpPr>
-          <p:cNvPr id="1981096830" name="Google Shape;144;p6"/>
+          <p:cNvPr id="713983725" name="Google Shape;144;p6"/>
           <p:cNvSpPr/>
           <p:nvPr/>
         </p:nvSpPr>
@@ -24735,7 +24735,7 @@
       </p:sp>
       <p:grpSp>
         <p:nvGrpSpPr>
-          <p:cNvPr id="1367124538" name="Google Shape;145;p6" descr="IT-CS 115: Vocabulary&#10;- Methods&#10;- Control Structures&#10;- Data Types&#10;"/>
+          <p:cNvPr id="1699421922" name="Google Shape;145;p6" descr="IT-CS 115: Vocabulary&#10;- Methods&#10;- Control Structures&#10;- Data Types&#10;"/>
           <p:cNvGrpSpPr/>
           <p:nvPr/>
         </p:nvGrpSpPr>
@@ -25083,7 +25083,7 @@
       </p:grpSp>
       <p:grpSp>
         <p:nvGrpSpPr>
-          <p:cNvPr id="443633303" name="Google Shape;150;p6" descr="IT-CS 142: Grammar&#10;- Using Data Structures&#10;- Object-Oriented Programming&#10;"/>
+          <p:cNvPr id="526528892" name="Google Shape;150;p6" descr="IT-CS 142: Grammar&#10;- Using Data Structures&#10;- Object-Oriented Programming&#10;"/>
           <p:cNvGrpSpPr/>
           <p:nvPr/>
         </p:nvGrpSpPr>
@@ -25420,7 +25420,7 @@
       </p:grpSp>
       <p:grpSp>
         <p:nvGrpSpPr>
-          <p:cNvPr id="1717984776" name="Google Shape;155;p6" descr="IT-CS 143: Structured Writing&#10;- Object Design&#10;- Data Abstraction&#10;- Algorithms&#10;"/>
+          <p:cNvPr id="1150406422" name="Google Shape;155;p6" descr="IT-CS 143: Structured Writing&#10;- Object Design&#10;- Data Abstraction&#10;- Algorithms&#10;"/>
           <p:cNvGrpSpPr/>
           <p:nvPr/>
         </p:nvGrpSpPr>
@@ -25818,7 +25818,7 @@
       </p:grpSp>
       <p:grpSp>
         <p:nvGrpSpPr>
-          <p:cNvPr id="1432160558" name="Google Shape;160;p6" descr="IT-CS 265:&#10;- Data Structure Design and Implementation&#10;- Algorithmic Design&#10;- Code Analysis&#10;"/>
+          <p:cNvPr id="1511100581" name="Google Shape;160;p6" descr="IT-CS 265:&#10;- Data Structure Design and Implementation&#10;- Algorithmic Design&#10;- Code Analysis&#10;"/>
           <p:cNvGrpSpPr/>
           <p:nvPr/>
         </p:nvGrpSpPr>
@@ -26216,7 +26216,7 @@
       </p:grpSp>
       <p:sp>
         <p:nvSpPr>
-          <p:cNvPr id="1478045319" name="Google Shape;165;p6"/>
+          <p:cNvPr id="1024595690" name="Google Shape;165;p6"/>
           <p:cNvSpPr/>
           <p:nvPr/>
         </p:nvSpPr>
@@ -26280,7 +26280,7 @@
       </p:sp>
       <p:sp>
         <p:nvSpPr>
-          <p:cNvPr id="841761561" name="Google Shape;166;p6"/>
+          <p:cNvPr id="29775094" name="Google Shape;166;p6"/>
           <p:cNvSpPr/>
           <p:nvPr/>
         </p:nvSpPr>
@@ -26344,7 +26344,7 @@
       </p:sp>
       <p:sp>
         <p:nvSpPr>
-          <p:cNvPr id="341399596" name="Google Shape;167;p6"/>
+          <p:cNvPr id="1743748059" name="Google Shape;167;p6"/>
           <p:cNvSpPr/>
           <p:nvPr/>
         </p:nvSpPr>
@@ -26408,7 +26408,7 @@
       </p:sp>
       <p:sp>
         <p:nvSpPr>
-          <p:cNvPr id="1457435573" name="Google Shape;168;p6"/>
+          <p:cNvPr id="1504017543" name="Google Shape;168;p6"/>
           <p:cNvSpPr/>
           <p:nvPr/>
         </p:nvSpPr>
@@ -26472,7 +26472,7 @@
       </p:sp>
       <p:sp>
         <p:nvSpPr>
-          <p:cNvPr id="2125371567" name="Google Shape;169;p6"/>
+          <p:cNvPr id="104850976" name="Google Shape;169;p6"/>
           <p:cNvSpPr/>
           <p:nvPr/>
         </p:nvSpPr>
@@ -26536,7 +26536,7 @@
       </p:sp>
       <p:sp>
         <p:nvSpPr>
-          <p:cNvPr id="488161599" name="Google Shape;170;p6"/>
+          <p:cNvPr id="964665833" name="Google Shape;170;p6"/>
           <p:cNvSpPr txBox="1"/>
           <p:nvPr/>
         </p:nvSpPr>
@@ -26601,7 +26601,7 @@
       </p:sp>
       <p:sp>
         <p:nvSpPr>
-          <p:cNvPr id="742714308" name="Google Shape;172;p6"/>
+          <p:cNvPr id="331926724" name="Google Shape;172;p6"/>
           <p:cNvSpPr txBox="1"/>
           <p:nvPr/>
         </p:nvSpPr>
@@ -27056,7 +27056,7 @@
       </p:sp>
       <p:sp>
         <p:nvSpPr>
-          <p:cNvPr id="316884151" name="Google Shape;171;p6"/>
+          <p:cNvPr id="1652911864" name="Google Shape;171;p6"/>
           <p:cNvSpPr txBox="1"/>
           <p:nvPr/>
         </p:nvSpPr>
@@ -27121,7 +27121,7 @@
       </p:sp>
       <p:sp>
         <p:nvSpPr>
-          <p:cNvPr id="1815276290" name="Google Shape;173;p6"/>
+          <p:cNvPr id="1541565030" name="Google Shape;173;p6"/>
           <p:cNvSpPr txBox="1">
             <a:spLocks noGrp="1"/>
           </p:cNvSpPr>
@@ -27217,7 +27217,7 @@
                                           </p:stCondLst>
                                         </p:cTn>
                                         <p:tgtEl>
-                                          <p:spTgt spid="1981096830"/>
+                                          <p:spTgt spid="713983725"/>
                                         </p:tgtEl>
                                         <p:attrNameLst>
                                           <p:attrName>style.visibility</p:attrName>
@@ -27244,7 +27244,7 @@
                                           </p:stCondLst>
                                         </p:cTn>
                                         <p:tgtEl>
-                                          <p:spTgt spid="443633303"/>
+                                          <p:spTgt spid="526528892"/>
                                         </p:tgtEl>
                                         <p:attrNameLst>
                                           <p:attrName>style.visibility</p:attrName>
@@ -27289,7 +27289,7 @@
                                           </p:stCondLst>
                                         </p:cTn>
                                         <p:tgtEl>
-                                          <p:spTgt spid="1478045319"/>
+                                          <p:spTgt spid="1024595690"/>
                                         </p:tgtEl>
                                         <p:attrNameLst>
                                           <p:attrName>style.visibility</p:attrName>
@@ -27316,7 +27316,7 @@
                                           </p:stCondLst>
                                         </p:cTn>
                                         <p:tgtEl>
-                                          <p:spTgt spid="1717984776"/>
+                                          <p:spTgt spid="1150406422"/>
                                         </p:tgtEl>
                                         <p:attrNameLst>
                                           <p:attrName>style.visibility</p:attrName>
@@ -27361,7 +27361,7 @@
                                           </p:stCondLst>
                                         </p:cTn>
                                         <p:tgtEl>
-                                          <p:spTgt spid="841761561"/>
+                                          <p:spTgt spid="29775094"/>
                                         </p:tgtEl>
                                         <p:attrNameLst>
                                           <p:attrName>style.visibility</p:attrName>
@@ -27388,7 +27388,7 @@
                                           </p:stCondLst>
                                         </p:cTn>
                                         <p:tgtEl>
-                                          <p:spTgt spid="1432160558"/>
+                                          <p:spTgt spid="1511100581"/>
                                         </p:tgtEl>
                                         <p:attrNameLst>
                                           <p:attrName>style.visibility</p:attrName>
@@ -27433,7 +27433,7 @@
                                           </p:stCondLst>
                                         </p:cTn>
                                         <p:tgtEl>
-                                          <p:spTgt spid="341399596"/>
+                                          <p:spTgt spid="1743748059"/>
                                         </p:tgtEl>
                                         <p:attrNameLst>
                                           <p:attrName>style.visibility</p:attrName>
@@ -27460,7 +27460,7 @@
                                           </p:stCondLst>
                                         </p:cTn>
                                         <p:tgtEl>
-                                          <p:spTgt spid="1457435573"/>
+                                          <p:spTgt spid="1504017543"/>
                                         </p:tgtEl>
                                         <p:attrNameLst>
                                           <p:attrName>style.visibility</p:attrName>
@@ -27487,7 +27487,7 @@
                                           </p:stCondLst>
                                         </p:cTn>
                                         <p:tgtEl>
-                                          <p:spTgt spid="2125371567"/>
+                                          <p:spTgt spid="104850976"/>
                                         </p:tgtEl>
                                         <p:attrNameLst>
                                           <p:attrName>style.visibility</p:attrName>
@@ -27514,7 +27514,7 @@
                                           </p:stCondLst>
                                         </p:cTn>
                                         <p:tgtEl>
-                                          <p:spTgt spid="488161599"/>
+                                          <p:spTgt spid="964665833"/>
                                         </p:tgtEl>
                                         <p:attrNameLst>
                                           <p:attrName>style.visibility</p:attrName>
@@ -27577,7 +27577,7 @@
       </p:grpSpPr>
       <p:sp>
         <p:nvSpPr>
-          <p:cNvPr id="72565163" name="Google Shape;178;g320ca67c64f_0_233"/>
+          <p:cNvPr id="330316532" name="Google Shape;178;g320ca67c64f_0_233"/>
           <p:cNvSpPr txBox="1">
             <a:spLocks noGrp="1"/>
           </p:cNvSpPr>
@@ -27620,7 +27620,7 @@
       </p:sp>
       <p:sp>
         <p:nvSpPr>
-          <p:cNvPr id="672995355" name="Google Shape;179;g320ca67c64f_0_233"/>
+          <p:cNvPr id="1291550158" name="Google Shape;179;g320ca67c64f_0_233"/>
           <p:cNvSpPr txBox="1">
             <a:spLocks noGrp="1"/>
           </p:cNvSpPr>
@@ -27756,7 +27756,7 @@
       </p:sp>
       <p:sp>
         <p:nvSpPr>
-          <p:cNvPr id="1580241855" name="Google Shape;180;g320ca67c64f_0_233"/>
+          <p:cNvPr id="586471231" name="Google Shape;180;g320ca67c64f_0_233"/>
           <p:cNvSpPr txBox="1">
             <a:spLocks noGrp="1"/>
           </p:cNvSpPr>
@@ -27832,7 +27832,7 @@
       </p:grpSpPr>
       <p:sp>
         <p:nvSpPr>
-          <p:cNvPr id="935411468" name="Google Shape;208;g320ca67c64f_0_259"/>
+          <p:cNvPr id="401307443" name="Google Shape;208;g320ca67c64f_0_259"/>
           <p:cNvSpPr txBox="1">
             <a:spLocks noGrp="1"/>
           </p:cNvSpPr>
@@ -27875,7 +27875,7 @@
       </p:sp>
       <p:sp>
         <p:nvSpPr>
-          <p:cNvPr id="1334296675" name="Google Shape;209;g320ca67c64f_0_259"/>
+          <p:cNvPr id="371504139" name="Google Shape;209;g320ca67c64f_0_259"/>
           <p:cNvSpPr txBox="1">
             <a:spLocks noGrp="1"/>
           </p:cNvSpPr>
@@ -28163,7 +28163,7 @@
       </p:sp>
       <p:sp>
         <p:nvSpPr>
-          <p:cNvPr id="118274081" name="Google Shape;210;g320ca67c64f_0_259"/>
+          <p:cNvPr id="249079686" name="Google Shape;210;g320ca67c64f_0_259"/>
           <p:cNvSpPr txBox="1">
             <a:spLocks noGrp="1"/>
           </p:cNvSpPr>
@@ -28239,7 +28239,7 @@
       </p:grpSpPr>
       <p:sp>
         <p:nvSpPr>
-          <p:cNvPr id="268051438" name="Google Shape;215;g320ca67c64f_0_265"/>
+          <p:cNvPr id="1353238611" name="Google Shape;215;g320ca67c64f_0_265"/>
           <p:cNvSpPr txBox="1">
             <a:spLocks noGrp="1"/>
           </p:cNvSpPr>
@@ -28282,7 +28282,7 @@
       </p:sp>
       <p:sp>
         <p:nvSpPr>
-          <p:cNvPr id="1877981221" name="Google Shape;216;g320ca67c64f_0_265"/>
+          <p:cNvPr id="938605179" name="Google Shape;216;g320ca67c64f_0_265"/>
           <p:cNvSpPr txBox="1">
             <a:spLocks noGrp="1"/>
           </p:cNvSpPr>
@@ -28393,7 +28393,7 @@
       </p:sp>
       <p:pic>
         <p:nvPicPr>
-          <p:cNvPr id="477961873" name="Google Shape;218;g320ca67c64f_0_265" descr="Click on Account on the left-hand bar of Canvas. Then click on Notifications."/>
+          <p:cNvPr id="1549180779" name="Google Shape;218;g320ca67c64f_0_265" descr="Click on Account on the left-hand bar of Canvas. Then click on Notifications."/>
           <p:cNvPicPr/>
           <p:nvPr/>
         </p:nvPicPr>
@@ -28419,7 +28419,7 @@
       </p:pic>
       <p:pic>
         <p:nvPicPr>
-          <p:cNvPr id="1326000017" name="Google Shape;219;g320ca67c64f_0_265" descr="Within notification settings. Adjust the push notifications and email options for due date, announcement, and grading."/>
+          <p:cNvPr id="1878968825" name="Google Shape;219;g320ca67c64f_0_265" descr="Within notification settings. Adjust the push notifications and email options for due date, announcement, and grading."/>
           <p:cNvPicPr/>
           <p:nvPr/>
         </p:nvPicPr>
@@ -28445,7 +28445,7 @@
       </p:pic>
       <p:sp>
         <p:nvSpPr>
-          <p:cNvPr id="927060547" name="Google Shape;217;g320ca67c64f_0_265"/>
+          <p:cNvPr id="502325881" name="Google Shape;217;g320ca67c64f_0_265"/>
           <p:cNvSpPr txBox="1">
             <a:spLocks noGrp="1"/>
           </p:cNvSpPr>
@@ -28521,7 +28521,7 @@
       </p:grpSpPr>
       <p:sp>
         <p:nvSpPr>
-          <p:cNvPr id="1361690380" name="Google Shape;177;p25"/>
+          <p:cNvPr id="624323210" name="Google Shape;177;p25"/>
           <p:cNvSpPr txBox="1">
             <a:spLocks noGrp="1"/>
           </p:cNvSpPr>
@@ -28564,7 +28564,7 @@
       </p:sp>
       <p:sp>
         <p:nvSpPr>
-          <p:cNvPr id="1136487627" name="Google Shape;178;p25"/>
+          <p:cNvPr id="1709855277" name="Google Shape;178;p25"/>
           <p:cNvSpPr txBox="1">
             <a:spLocks noGrp="1"/>
           </p:cNvSpPr>
@@ -28815,7 +28815,7 @@
       </p:sp>
       <p:sp>
         <p:nvSpPr>
-          <p:cNvPr id="1630592936" name="Google Shape;179;p25"/>
+          <p:cNvPr id="1679764739" name="Google Shape;179;p25"/>
           <p:cNvSpPr txBox="1">
             <a:spLocks noGrp="1"/>
           </p:cNvSpPr>
@@ -28915,7 +28915,7 @@
       </p:grpSpPr>
       <p:sp>
         <p:nvSpPr>
-          <p:cNvPr id="265936473" name="Title 1"/>
+          <p:cNvPr id="1620609265" name="Title 1"/>
           <p:cNvSpPr>
             <a:spLocks noGrp="1"/>
           </p:cNvSpPr>
@@ -28941,7 +28941,7 @@
       </p:sp>
       <p:sp>
         <p:nvSpPr>
-          <p:cNvPr id="437452562" name="Slide Number Placeholder 2"/>
+          <p:cNvPr id="799728541" name="Slide Number Placeholder 2"/>
           <p:cNvSpPr>
             <a:spLocks noGrp="1"/>
           </p:cNvSpPr>

</xml_diff>